<commit_message>
docs: add DAG harness slide to marketing decks
</commit_message>
<xml_diff>
--- a/Marketing/Decks/VL-Master-Deck.pptx
+++ b/Marketing/Decks/VL-Master-Deck.pptx
@@ -24,9 +24,10 @@
     <p:sldId id="272" r:id="rId18"/>
     <p:sldId id="273" r:id="rId19"/>
     <p:sldId id="274" r:id="rId20"/>
+    <p:sldId id="275" r:id="rId21"/>
   </p:sldIdLst>
   <p:notesMasterIdLst>
-    <p:notesMasterId r:id="rId21"/>
+    <p:notesMasterId r:id="rId22"/>
   </p:notesMasterIdLst>
   <p:sldSz cx="12191695" cy="6858000"/>
   <p:notesSz cx="6858000" cy="12191695"/>
@@ -1512,6 +1513,94 @@
             <a:fld id="{F7021451-1387-4CA6-816F-3879F97B5CBC}" type="slidenum">
               <a:rPr lang="en-US"/>
               <a:t>2</a:t>
+            </a:fld>
+            <a:endParaRPr lang="en-US"/>
+          </a:p>
+        </p:txBody>
+      </p:sp>
+    </p:spTree>
+    <p:extLst>
+      <p:ext uri="{BB962C8B-B14F-4D97-AF65-F5344CB8AC3E}">
+        <p14:creationId xmlns:p14="http://schemas.microsoft.com/office/powerpoint/2010/main" val="1024086991"/>
+      </p:ext>
+    </p:extLst>
+  </p:cSld>
+  <p:clrMapOvr>
+    <a:masterClrMapping/>
+  </p:clrMapOvr>
+</p:notes>
+</file>
+
+<file path=ppt/notesSlides/notesSlide20.xml><?xml version="1.0" encoding="utf-8"?>
+<p:notes xmlns:a="http://schemas.openxmlformats.org/drawingml/2006/main" xmlns:r="http://schemas.openxmlformats.org/officeDocument/2006/relationships" xmlns:p="http://schemas.openxmlformats.org/presentationml/2006/main">
+  <p:cSld>
+    <p:spTree>
+      <p:nvGrpSpPr>
+        <p:cNvPr id="1" name=""/>
+        <p:cNvGrpSpPr/>
+        <p:nvPr/>
+      </p:nvGrpSpPr>
+      <p:grpSpPr>
+        <a:xfrm>
+          <a:off x="0" y="0"/>
+          <a:ext cx="0" cy="0"/>
+          <a:chOff x="0" y="0"/>
+          <a:chExt cx="0" cy="0"/>
+        </a:xfrm>
+      </p:grpSpPr>
+      <p:sp>
+        <p:nvSpPr>
+          <p:cNvPr id="2" name="Slide Image Placeholder 1"/>
+          <p:cNvSpPr>
+            <a:spLocks noGrp="1" noRot="1" noChangeAspect="1"/>
+          </p:cNvSpPr>
+          <p:nvPr>
+            <p:ph type="sldImg"/>
+          </p:nvPr>
+        </p:nvSpPr>
+        <p:spPr/>
+      </p:sp>
+      <p:sp>
+        <p:nvSpPr>
+          <p:cNvPr id="3" name="Notes Placeholder 2"/>
+          <p:cNvSpPr>
+            <a:spLocks noGrp="1"/>
+          </p:cNvSpPr>
+          <p:nvPr>
+            <p:ph type="body" idx="1"/>
+          </p:nvPr>
+        </p:nvSpPr>
+        <p:spPr/>
+        <p:txBody>
+          <a:bodyPr/>
+          <a:lstStyle/>
+          <a:p>
+            <a:r>
+              <a:rPr lang="en-US" dirty="0"/>
+              <a:t/>
+            </a:r>
+            <a:endParaRPr lang="en-US" dirty="0"/>
+          </a:p>
+        </p:txBody>
+      </p:sp>
+      <p:sp>
+        <p:nvSpPr>
+          <p:cNvPr id="4" name="Slide Number Placeholder 3"/>
+          <p:cNvSpPr>
+            <a:spLocks noGrp="1"/>
+          </p:cNvSpPr>
+          <p:nvPr>
+            <p:ph type="sldNum" sz="quarter" idx="10"/>
+          </p:nvPr>
+        </p:nvSpPr>
+        <p:spPr/>
+        <p:txBody>
+          <a:bodyPr/>
+          <a:lstStyle/>
+          <a:p>
+            <a:fld id="{F7021451-1387-4CA6-816F-3879F97B5CBC}" type="slidenum">
+              <a:rPr lang="en-US"/>
+              <a:t>20</a:t>
             </a:fld>
             <a:endParaRPr lang="en-US"/>
           </a:p>
@@ -9176,7 +9265,7 @@
                 <a:ea typeface="Helvetica Neue" pitchFamily="34" charset="-122"/>
                 <a:cs typeface="Helvetica Neue" pitchFamily="34" charset="-120"/>
               </a:rPr>
-              <a:t>16</a:t>
+              <a:t>15</a:t>
             </a:r>
             <a:endParaRPr lang="en-US" sz="1300" dirty="0"/>
           </a:p>
@@ -9215,7 +9304,7 @@
                 <a:ea typeface="Helvetica Neue" pitchFamily="34" charset="-122"/>
                 <a:cs typeface="Helvetica Neue" pitchFamily="34" charset="-120"/>
               </a:rPr>
-              <a:t>TEAM + COST</a:t>
+              <a:t>DAG HARNESS</a:t>
             </a:r>
             <a:endParaRPr lang="en-US" sz="1150" dirty="0"/>
           </a:p>
@@ -9230,7 +9319,7 @@
         <p:spPr>
           <a:xfrm>
             <a:off x="566928" y="1097280"/>
-            <a:ext cx="11057839" cy="1051560"/>
+            <a:ext cx="11057839" cy="914400"/>
           </a:xfrm>
           <a:prstGeom prst="rect">
             <a:avLst/>
@@ -9249,7 +9338,7 @@
               <a:buNone/>
             </a:pPr>
             <a:r>
-              <a:rPr lang="en-US" sz="3300" b="1" dirty="0">
+              <a:rPr lang="en-US" sz="2900" b="1" dirty="0">
                 <a:solidFill>
                   <a:srgbClr val="0F1B2E"/>
                 </a:solidFill>
@@ -9257,7 +9346,7 @@
                 <a:ea typeface="Helvetica Neue" pitchFamily="34" charset="-122"/>
                 <a:cs typeface="Helvetica Neue" pitchFamily="34" charset="-120"/>
               </a:rPr>
-              <a:t>Collaborate without </a:t>
+              <a:t>One AI node creates output. </a:t>
             </a:r>
             <a:pPr algn="l" indent="0" marL="0">
               <a:lnSpc>
@@ -9266,7 +9355,7 @@
               <a:buNone/>
             </a:pPr>
             <a:r>
-              <a:rPr lang="en-US" sz="3300" b="1" dirty="0">
+              <a:rPr lang="en-US" sz="2900" b="1" dirty="0">
                 <a:solidFill>
                   <a:srgbClr val="0E9F91"/>
                 </a:solidFill>
@@ -9274,26 +9363,9 @@
                 <a:ea typeface="Helvetica Neue" pitchFamily="34" charset="-122"/>
                 <a:cs typeface="Helvetica Neue" pitchFamily="34" charset="-120"/>
               </a:rPr>
-              <a:t>competing for lines</a:t>
-            </a:r>
-            <a:pPr algn="l" indent="0" marL="0">
-              <a:lnSpc>
-                <a:spcPct val="102000"/>
-              </a:lnSpc>
-              <a:buNone/>
-            </a:pPr>
-            <a:r>
-              <a:rPr lang="en-US" sz="3300" b="1" dirty="0">
-                <a:solidFill>
-                  <a:srgbClr val="0F1B2E"/>
-                </a:solidFill>
-                <a:latin typeface="Helvetica Neue" pitchFamily="34" charset="0"/>
-                <a:ea typeface="Helvetica Neue" pitchFamily="34" charset="-122"/>
-                <a:cs typeface="Helvetica Neue" pitchFamily="34" charset="-120"/>
-              </a:rPr>
-              <a:t>.</a:t>
-            </a:r>
-            <a:endParaRPr lang="en-US" sz="3300" dirty="0"/>
+              <a:t>A DAG harness creates progress.</a:t>
+            </a:r>
+            <a:endParaRPr lang="en-US" sz="2900" dirty="0"/>
           </a:p>
         </p:txBody>
       </p:sp>
@@ -9305,12 +9377,12 @@
         </p:nvSpPr>
         <p:spPr>
           <a:xfrm>
-            <a:off x="566928" y="2560320"/>
-            <a:ext cx="5300320" cy="2743200"/>
+            <a:off x="566928" y="1874520"/>
+            <a:ext cx="4800600" cy="3611880"/>
           </a:xfrm>
           <a:prstGeom prst="roundRect">
             <a:avLst>
-              <a:gd name="adj" fmla="val 3000"/>
+              <a:gd name="adj" fmla="val 2278"/>
             </a:avLst>
           </a:prstGeom>
           <a:solidFill>
@@ -9333,34 +9405,698 @@
       </p:sp>
       <p:sp>
         <p:nvSpPr>
-          <p:cNvPr id="7" name="Shape 5"/>
-          <p:cNvSpPr/>
-          <p:nvPr/>
-        </p:nvSpPr>
-        <p:spPr>
-          <a:xfrm>
-            <a:off x="886968" y="2880360"/>
-            <a:ext cx="457200" cy="73152"/>
-          </a:xfrm>
-          <a:prstGeom prst="rect">
-            <a:avLst/>
+          <p:cNvPr id="7" name="Text 5"/>
+          <p:cNvSpPr/>
+          <p:nvPr/>
+        </p:nvSpPr>
+        <p:spPr>
+          <a:xfrm>
+            <a:off x="877824" y="2130552"/>
+            <a:ext cx="1463040" cy="219456"/>
+          </a:xfrm>
+          <a:prstGeom prst="rect">
+            <a:avLst/>
+          </a:prstGeom>
+          <a:noFill/>
+          <a:ln/>
+        </p:spPr>
+        <p:txBody>
+          <a:bodyPr wrap="square" lIns="0" tIns="0" rIns="0" bIns="0" rtlCol="0" anchor="ctr"/>
+          <a:lstStyle/>
+          <a:p>
+            <a:pPr indent="0" marL="0">
+              <a:buNone/>
+            </a:pPr>
+            <a:r>
+              <a:rPr lang="en-US" sz="1500" b="1" dirty="0">
+                <a:solidFill>
+                  <a:srgbClr val="0F1B2E"/>
+                </a:solidFill>
+                <a:latin typeface="Helvetica Neue" pitchFamily="34" charset="0"/>
+                <a:ea typeface="Helvetica Neue" pitchFamily="34" charset="-122"/>
+                <a:cs typeface="Helvetica Neue" pitchFamily="34" charset="-120"/>
+              </a:rPr>
+              <a:t>Point AI</a:t>
+            </a:r>
+            <a:endParaRPr lang="en-US" sz="1500" dirty="0"/>
+          </a:p>
+        </p:txBody>
+      </p:sp>
+      <p:sp>
+        <p:nvSpPr>
+          <p:cNvPr id="8" name="Text 6"/>
+          <p:cNvSpPr/>
+          <p:nvPr/>
+        </p:nvSpPr>
+        <p:spPr>
+          <a:xfrm>
+            <a:off x="2258568" y="2157984"/>
+            <a:ext cx="2606040" cy="164592"/>
+          </a:xfrm>
+          <a:prstGeom prst="rect">
+            <a:avLst/>
+          </a:prstGeom>
+          <a:noFill/>
+          <a:ln/>
+        </p:spPr>
+        <p:txBody>
+          <a:bodyPr wrap="square" lIns="0" tIns="0" rIns="0" bIns="0" rtlCol="0" anchor="ctr"/>
+          <a:lstStyle/>
+          <a:p>
+            <a:pPr indent="0" marL="0">
+              <a:buNone/>
+            </a:pPr>
+            <a:r>
+              <a:rPr lang="en-US" sz="950" dirty="0">
+                <a:solidFill>
+                  <a:srgbClr val="6B7C93"/>
+                </a:solidFill>
+                <a:latin typeface="Helvetica Neue" pitchFamily="34" charset="0"/>
+                <a:ea typeface="Helvetica Neue" pitchFamily="34" charset="-122"/>
+                <a:cs typeface="Helvetica Neue" pitchFamily="34" charset="-120"/>
+              </a:rPr>
+              <a:t>many inputs → one powerful output</a:t>
+            </a:r>
+            <a:endParaRPr lang="en-US" sz="950" dirty="0"/>
+          </a:p>
+        </p:txBody>
+      </p:sp>
+      <p:sp>
+        <p:nvSpPr>
+          <p:cNvPr id="9" name="Shape 7"/>
+          <p:cNvSpPr/>
+          <p:nvPr/>
+        </p:nvSpPr>
+        <p:spPr>
+          <a:xfrm>
+            <a:off x="877824" y="2788920"/>
+            <a:ext cx="960120" cy="256032"/>
+          </a:xfrm>
+          <a:prstGeom prst="roundRect">
+            <a:avLst>
+              <a:gd name="adj" fmla="val 17857"/>
+            </a:avLst>
+          </a:prstGeom>
+          <a:solidFill>
+            <a:srgbClr val="EAF2F8"/>
+          </a:solidFill>
+          <a:ln w="12700">
+            <a:solidFill>
+              <a:srgbClr val="E4EAF1"/>
+            </a:solidFill>
+            <a:prstDash val="solid"/>
+          </a:ln>
+        </p:spPr>
+      </p:sp>
+      <p:sp>
+        <p:nvSpPr>
+          <p:cNvPr id="10" name="Text 8"/>
+          <p:cNvSpPr/>
+          <p:nvPr/>
+        </p:nvSpPr>
+        <p:spPr>
+          <a:xfrm>
+            <a:off x="877824" y="2862072"/>
+            <a:ext cx="960120" cy="73152"/>
+          </a:xfrm>
+          <a:prstGeom prst="rect">
+            <a:avLst/>
+          </a:prstGeom>
+          <a:noFill/>
+          <a:ln/>
+        </p:spPr>
+        <p:txBody>
+          <a:bodyPr wrap="square" lIns="0" tIns="0" rIns="0" bIns="0" rtlCol="0" anchor="ctr"/>
+          <a:lstStyle/>
+          <a:p>
+            <a:pPr algn="ctr" indent="0" marL="0">
+              <a:buNone/>
+            </a:pPr>
+            <a:r>
+              <a:rPr lang="en-US" sz="760" b="1" dirty="0">
+                <a:solidFill>
+                  <a:srgbClr val="2A3A51"/>
+                </a:solidFill>
+                <a:latin typeface="Helvetica Neue" pitchFamily="34" charset="0"/>
+                <a:ea typeface="Helvetica Neue" pitchFamily="34" charset="-122"/>
+                <a:cs typeface="Helvetica Neue" pitchFamily="34" charset="-120"/>
+              </a:rPr>
+              <a:t>Prompt</a:t>
+            </a:r>
+            <a:endParaRPr lang="en-US" sz="760" dirty="0"/>
+          </a:p>
+        </p:txBody>
+      </p:sp>
+      <p:sp>
+        <p:nvSpPr>
+          <p:cNvPr id="11" name="Shape 9"/>
+          <p:cNvSpPr/>
+          <p:nvPr/>
+        </p:nvSpPr>
+        <p:spPr>
+          <a:xfrm>
+            <a:off x="1865376" y="2916936"/>
+            <a:ext cx="914400" cy="1609344"/>
+          </a:xfrm>
+          <a:prstGeom prst="line">
+            <a:avLst/>
+          </a:prstGeom>
+          <a:noFill/>
+          <a:ln w="12700">
+            <a:solidFill>
+              <a:srgbClr val="E4EAF1"/>
+            </a:solidFill>
+            <a:prstDash val="solid"/>
+            <a:tailEnd type="triangle"/>
+          </a:ln>
+        </p:spPr>
+      </p:sp>
+      <p:sp>
+        <p:nvSpPr>
+          <p:cNvPr id="12" name="Shape 10"/>
+          <p:cNvSpPr/>
+          <p:nvPr/>
+        </p:nvSpPr>
+        <p:spPr>
+          <a:xfrm>
+            <a:off x="877824" y="3209544"/>
+            <a:ext cx="960120" cy="256032"/>
+          </a:xfrm>
+          <a:prstGeom prst="roundRect">
+            <a:avLst>
+              <a:gd name="adj" fmla="val 17857"/>
+            </a:avLst>
+          </a:prstGeom>
+          <a:solidFill>
+            <a:srgbClr val="EAF2F8"/>
+          </a:solidFill>
+          <a:ln w="12700">
+            <a:solidFill>
+              <a:srgbClr val="E4EAF1"/>
+            </a:solidFill>
+            <a:prstDash val="solid"/>
+          </a:ln>
+        </p:spPr>
+      </p:sp>
+      <p:sp>
+        <p:nvSpPr>
+          <p:cNvPr id="13" name="Text 11"/>
+          <p:cNvSpPr/>
+          <p:nvPr/>
+        </p:nvSpPr>
+        <p:spPr>
+          <a:xfrm>
+            <a:off x="877824" y="3282696"/>
+            <a:ext cx="960120" cy="73152"/>
+          </a:xfrm>
+          <a:prstGeom prst="rect">
+            <a:avLst/>
+          </a:prstGeom>
+          <a:noFill/>
+          <a:ln/>
+        </p:spPr>
+        <p:txBody>
+          <a:bodyPr wrap="square" lIns="0" tIns="0" rIns="0" bIns="0" rtlCol="0" anchor="ctr"/>
+          <a:lstStyle/>
+          <a:p>
+            <a:pPr algn="ctr" indent="0" marL="0">
+              <a:buNone/>
+            </a:pPr>
+            <a:r>
+              <a:rPr lang="en-US" sz="760" b="1" dirty="0">
+                <a:solidFill>
+                  <a:srgbClr val="2A3A51"/>
+                </a:solidFill>
+                <a:latin typeface="Helvetica Neue" pitchFamily="34" charset="0"/>
+                <a:ea typeface="Helvetica Neue" pitchFamily="34" charset="-122"/>
+                <a:cs typeface="Helvetica Neue" pitchFamily="34" charset="-120"/>
+              </a:rPr>
+              <a:t>Docs</a:t>
+            </a:r>
+            <a:endParaRPr lang="en-US" sz="760" dirty="0"/>
+          </a:p>
+        </p:txBody>
+      </p:sp>
+      <p:sp>
+        <p:nvSpPr>
+          <p:cNvPr id="14" name="Shape 12"/>
+          <p:cNvSpPr/>
+          <p:nvPr/>
+        </p:nvSpPr>
+        <p:spPr>
+          <a:xfrm>
+            <a:off x="1865376" y="3337560"/>
+            <a:ext cx="914400" cy="1188720"/>
+          </a:xfrm>
+          <a:prstGeom prst="line">
+            <a:avLst/>
+          </a:prstGeom>
+          <a:noFill/>
+          <a:ln w="12700">
+            <a:solidFill>
+              <a:srgbClr val="E4EAF1"/>
+            </a:solidFill>
+            <a:prstDash val="solid"/>
+            <a:tailEnd type="triangle"/>
+          </a:ln>
+        </p:spPr>
+      </p:sp>
+      <p:sp>
+        <p:nvSpPr>
+          <p:cNvPr id="15" name="Shape 13"/>
+          <p:cNvSpPr/>
+          <p:nvPr/>
+        </p:nvSpPr>
+        <p:spPr>
+          <a:xfrm>
+            <a:off x="877824" y="3630168"/>
+            <a:ext cx="960120" cy="256032"/>
+          </a:xfrm>
+          <a:prstGeom prst="roundRect">
+            <a:avLst>
+              <a:gd name="adj" fmla="val 17857"/>
+            </a:avLst>
+          </a:prstGeom>
+          <a:solidFill>
+            <a:srgbClr val="EAF2F8"/>
+          </a:solidFill>
+          <a:ln w="12700">
+            <a:solidFill>
+              <a:srgbClr val="E4EAF1"/>
+            </a:solidFill>
+            <a:prstDash val="solid"/>
+          </a:ln>
+        </p:spPr>
+      </p:sp>
+      <p:sp>
+        <p:nvSpPr>
+          <p:cNvPr id="16" name="Text 14"/>
+          <p:cNvSpPr/>
+          <p:nvPr/>
+        </p:nvSpPr>
+        <p:spPr>
+          <a:xfrm>
+            <a:off x="877824" y="3703320"/>
+            <a:ext cx="960120" cy="73152"/>
+          </a:xfrm>
+          <a:prstGeom prst="rect">
+            <a:avLst/>
+          </a:prstGeom>
+          <a:noFill/>
+          <a:ln/>
+        </p:spPr>
+        <p:txBody>
+          <a:bodyPr wrap="square" lIns="0" tIns="0" rIns="0" bIns="0" rtlCol="0" anchor="ctr"/>
+          <a:lstStyle/>
+          <a:p>
+            <a:pPr algn="ctr" indent="0" marL="0">
+              <a:buNone/>
+            </a:pPr>
+            <a:r>
+              <a:rPr lang="en-US" sz="760" b="1" dirty="0">
+                <a:solidFill>
+                  <a:srgbClr val="2A3A51"/>
+                </a:solidFill>
+                <a:latin typeface="Helvetica Neue" pitchFamily="34" charset="0"/>
+                <a:ea typeface="Helvetica Neue" pitchFamily="34" charset="-122"/>
+                <a:cs typeface="Helvetica Neue" pitchFamily="34" charset="-120"/>
+              </a:rPr>
+              <a:t>Code</a:t>
+            </a:r>
+            <a:endParaRPr lang="en-US" sz="760" dirty="0"/>
+          </a:p>
+        </p:txBody>
+      </p:sp>
+      <p:sp>
+        <p:nvSpPr>
+          <p:cNvPr id="17" name="Shape 15"/>
+          <p:cNvSpPr/>
+          <p:nvPr/>
+        </p:nvSpPr>
+        <p:spPr>
+          <a:xfrm>
+            <a:off x="1865376" y="3758184"/>
+            <a:ext cx="914400" cy="768096"/>
+          </a:xfrm>
+          <a:prstGeom prst="line">
+            <a:avLst/>
+          </a:prstGeom>
+          <a:noFill/>
+          <a:ln w="12700">
+            <a:solidFill>
+              <a:srgbClr val="E4EAF1"/>
+            </a:solidFill>
+            <a:prstDash val="solid"/>
+            <a:tailEnd type="triangle"/>
+          </a:ln>
+        </p:spPr>
+      </p:sp>
+      <p:sp>
+        <p:nvSpPr>
+          <p:cNvPr id="18" name="Shape 16"/>
+          <p:cNvSpPr/>
+          <p:nvPr/>
+        </p:nvSpPr>
+        <p:spPr>
+          <a:xfrm>
+            <a:off x="877824" y="4050792"/>
+            <a:ext cx="960120" cy="256032"/>
+          </a:xfrm>
+          <a:prstGeom prst="roundRect">
+            <a:avLst>
+              <a:gd name="adj" fmla="val 17857"/>
+            </a:avLst>
+          </a:prstGeom>
+          <a:solidFill>
+            <a:srgbClr val="EAF2F8"/>
+          </a:solidFill>
+          <a:ln w="12700">
+            <a:solidFill>
+              <a:srgbClr val="E4EAF1"/>
+            </a:solidFill>
+            <a:prstDash val="solid"/>
+          </a:ln>
+        </p:spPr>
+      </p:sp>
+      <p:sp>
+        <p:nvSpPr>
+          <p:cNvPr id="19" name="Text 17"/>
+          <p:cNvSpPr/>
+          <p:nvPr/>
+        </p:nvSpPr>
+        <p:spPr>
+          <a:xfrm>
+            <a:off x="877824" y="4123944"/>
+            <a:ext cx="960120" cy="73152"/>
+          </a:xfrm>
+          <a:prstGeom prst="rect">
+            <a:avLst/>
+          </a:prstGeom>
+          <a:noFill/>
+          <a:ln/>
+        </p:spPr>
+        <p:txBody>
+          <a:bodyPr wrap="square" lIns="0" tIns="0" rIns="0" bIns="0" rtlCol="0" anchor="ctr"/>
+          <a:lstStyle/>
+          <a:p>
+            <a:pPr algn="ctr" indent="0" marL="0">
+              <a:buNone/>
+            </a:pPr>
+            <a:r>
+              <a:rPr lang="en-US" sz="760" b="1" dirty="0">
+                <a:solidFill>
+                  <a:srgbClr val="2A3A51"/>
+                </a:solidFill>
+                <a:latin typeface="Helvetica Neue" pitchFamily="34" charset="0"/>
+                <a:ea typeface="Helvetica Neue" pitchFamily="34" charset="-122"/>
+                <a:cs typeface="Helvetica Neue" pitchFamily="34" charset="-120"/>
+              </a:rPr>
+              <a:t>Data</a:t>
+            </a:r>
+            <a:endParaRPr lang="en-US" sz="760" dirty="0"/>
+          </a:p>
+        </p:txBody>
+      </p:sp>
+      <p:sp>
+        <p:nvSpPr>
+          <p:cNvPr id="20" name="Shape 18"/>
+          <p:cNvSpPr/>
+          <p:nvPr/>
+        </p:nvSpPr>
+        <p:spPr>
+          <a:xfrm>
+            <a:off x="1865376" y="4178808"/>
+            <a:ext cx="914400" cy="347472"/>
+          </a:xfrm>
+          <a:prstGeom prst="line">
+            <a:avLst/>
+          </a:prstGeom>
+          <a:noFill/>
+          <a:ln w="12700">
+            <a:solidFill>
+              <a:srgbClr val="E4EAF1"/>
+            </a:solidFill>
+            <a:prstDash val="solid"/>
+            <a:tailEnd type="triangle"/>
+          </a:ln>
+        </p:spPr>
+      </p:sp>
+      <p:sp>
+        <p:nvSpPr>
+          <p:cNvPr id="21" name="Shape 19"/>
+          <p:cNvSpPr/>
+          <p:nvPr/>
+        </p:nvSpPr>
+        <p:spPr>
+          <a:xfrm>
+            <a:off x="877824" y="4471416"/>
+            <a:ext cx="960120" cy="256032"/>
+          </a:xfrm>
+          <a:prstGeom prst="roundRect">
+            <a:avLst>
+              <a:gd name="adj" fmla="val 17857"/>
+            </a:avLst>
+          </a:prstGeom>
+          <a:solidFill>
+            <a:srgbClr val="EAF2F8"/>
+          </a:solidFill>
+          <a:ln w="12700">
+            <a:solidFill>
+              <a:srgbClr val="E4EAF1"/>
+            </a:solidFill>
+            <a:prstDash val="solid"/>
+          </a:ln>
+        </p:spPr>
+      </p:sp>
+      <p:sp>
+        <p:nvSpPr>
+          <p:cNvPr id="22" name="Text 20"/>
+          <p:cNvSpPr/>
+          <p:nvPr/>
+        </p:nvSpPr>
+        <p:spPr>
+          <a:xfrm>
+            <a:off x="877824" y="4544568"/>
+            <a:ext cx="960120" cy="73152"/>
+          </a:xfrm>
+          <a:prstGeom prst="rect">
+            <a:avLst/>
+          </a:prstGeom>
+          <a:noFill/>
+          <a:ln/>
+        </p:spPr>
+        <p:txBody>
+          <a:bodyPr wrap="square" lIns="0" tIns="0" rIns="0" bIns="0" rtlCol="0" anchor="ctr"/>
+          <a:lstStyle/>
+          <a:p>
+            <a:pPr algn="ctr" indent="0" marL="0">
+              <a:buNone/>
+            </a:pPr>
+            <a:r>
+              <a:rPr lang="en-US" sz="760" b="1" dirty="0">
+                <a:solidFill>
+                  <a:srgbClr val="2A3A51"/>
+                </a:solidFill>
+                <a:latin typeface="Helvetica Neue" pitchFamily="34" charset="0"/>
+                <a:ea typeface="Helvetica Neue" pitchFamily="34" charset="-122"/>
+                <a:cs typeface="Helvetica Neue" pitchFamily="34" charset="-120"/>
+              </a:rPr>
+              <a:t>Tools</a:t>
+            </a:r>
+            <a:endParaRPr lang="en-US" sz="760" dirty="0"/>
+          </a:p>
+        </p:txBody>
+      </p:sp>
+      <p:sp>
+        <p:nvSpPr>
+          <p:cNvPr id="23" name="Shape 21"/>
+          <p:cNvSpPr/>
+          <p:nvPr/>
+        </p:nvSpPr>
+        <p:spPr>
+          <a:xfrm>
+            <a:off x="1865376" y="4599432"/>
+            <a:ext cx="914400" cy="-73152"/>
+          </a:xfrm>
+          <a:prstGeom prst="line">
+            <a:avLst/>
+          </a:prstGeom>
+          <a:noFill/>
+          <a:ln w="12700">
+            <a:solidFill>
+              <a:srgbClr val="E4EAF1"/>
+            </a:solidFill>
+            <a:prstDash val="solid"/>
+            <a:tailEnd type="triangle"/>
+          </a:ln>
+        </p:spPr>
+      </p:sp>
+      <p:sp>
+        <p:nvSpPr>
+          <p:cNvPr id="24" name="Shape 22"/>
+          <p:cNvSpPr/>
+          <p:nvPr/>
+        </p:nvSpPr>
+        <p:spPr>
+          <a:xfrm>
+            <a:off x="2852928" y="3483864"/>
+            <a:ext cx="1143000" cy="658368"/>
+          </a:xfrm>
+          <a:prstGeom prst="roundRect">
+            <a:avLst>
+              <a:gd name="adj" fmla="val 16667"/>
+            </a:avLst>
+          </a:prstGeom>
+          <a:solidFill>
+            <a:srgbClr val="0A1526"/>
+          </a:solidFill>
+          <a:ln w="12700">
+            <a:solidFill>
+              <a:srgbClr val="0A1526"/>
+            </a:solidFill>
+            <a:prstDash val="solid"/>
+          </a:ln>
+        </p:spPr>
+      </p:sp>
+      <p:sp>
+        <p:nvSpPr>
+          <p:cNvPr id="25" name="Text 23"/>
+          <p:cNvSpPr/>
+          <p:nvPr/>
+        </p:nvSpPr>
+        <p:spPr>
+          <a:xfrm>
+            <a:off x="2852928" y="3694176"/>
+            <a:ext cx="1143000" cy="146304"/>
+          </a:xfrm>
+          <a:prstGeom prst="rect">
+            <a:avLst/>
+          </a:prstGeom>
+          <a:noFill/>
+          <a:ln/>
+        </p:spPr>
+        <p:txBody>
+          <a:bodyPr wrap="square" lIns="0" tIns="0" rIns="0" bIns="0" rtlCol="0" anchor="ctr"/>
+          <a:lstStyle/>
+          <a:p>
+            <a:pPr algn="ctr" indent="0" marL="0">
+              <a:buNone/>
+            </a:pPr>
+            <a:r>
+              <a:rPr lang="en-US" sz="1800" b="1" dirty="0">
+                <a:solidFill>
+                  <a:srgbClr val="7FE7DA"/>
+                </a:solidFill>
+                <a:latin typeface="Helvetica Neue" pitchFamily="34" charset="0"/>
+                <a:ea typeface="Helvetica Neue" pitchFamily="34" charset="-122"/>
+                <a:cs typeface="Helvetica Neue" pitchFamily="34" charset="-120"/>
+              </a:rPr>
+              <a:t>AI</a:t>
+            </a:r>
+            <a:endParaRPr lang="en-US" sz="1800" dirty="0"/>
+          </a:p>
+        </p:txBody>
+      </p:sp>
+      <p:sp>
+        <p:nvSpPr>
+          <p:cNvPr id="26" name="Shape 24"/>
+          <p:cNvSpPr/>
+          <p:nvPr/>
+        </p:nvSpPr>
+        <p:spPr>
+          <a:xfrm>
+            <a:off x="4023360" y="3813048"/>
+            <a:ext cx="594360" cy="0"/>
+          </a:xfrm>
+          <a:prstGeom prst="line">
+            <a:avLst/>
+          </a:prstGeom>
+          <a:noFill/>
+          <a:ln w="20320">
+            <a:solidFill>
+              <a:srgbClr val="0E9F91"/>
+            </a:solidFill>
+            <a:prstDash val="solid"/>
+            <a:tailEnd type="triangle"/>
+          </a:ln>
+        </p:spPr>
+      </p:sp>
+      <p:sp>
+        <p:nvSpPr>
+          <p:cNvPr id="27" name="Shape 25"/>
+          <p:cNvSpPr/>
+          <p:nvPr/>
+        </p:nvSpPr>
+        <p:spPr>
+          <a:xfrm>
+            <a:off x="4663440" y="3447288"/>
+            <a:ext cx="384048" cy="749808"/>
+          </a:xfrm>
+          <a:prstGeom prst="roundRect">
+            <a:avLst>
+              <a:gd name="adj" fmla="val 19048"/>
+            </a:avLst>
           </a:prstGeom>
           <a:solidFill>
             <a:srgbClr val="15B3A4"/>
           </a:solidFill>
-          <a:ln/>
-        </p:spPr>
-      </p:sp>
-      <p:sp>
-        <p:nvSpPr>
-          <p:cNvPr id="8" name="Text 6"/>
-          <p:cNvSpPr/>
-          <p:nvPr/>
-        </p:nvSpPr>
-        <p:spPr>
-          <a:xfrm>
-            <a:off x="886968" y="3017520"/>
-            <a:ext cx="4660240" cy="502920"/>
+          <a:ln w="12700">
+            <a:solidFill>
+              <a:srgbClr val="15B3A4"/>
+            </a:solidFill>
+            <a:prstDash val="solid"/>
+          </a:ln>
+        </p:spPr>
+      </p:sp>
+      <p:sp>
+        <p:nvSpPr>
+          <p:cNvPr id="28" name="Text 26"/>
+          <p:cNvSpPr/>
+          <p:nvPr/>
+        </p:nvSpPr>
+        <p:spPr>
+          <a:xfrm rot="5400000">
+            <a:off x="4572000" y="3749040"/>
+            <a:ext cx="566928" cy="73152"/>
+          </a:xfrm>
+          <a:prstGeom prst="rect">
+            <a:avLst/>
+          </a:prstGeom>
+          <a:noFill/>
+          <a:ln/>
+        </p:spPr>
+        <p:txBody>
+          <a:bodyPr wrap="square" lIns="0" tIns="0" rIns="0" bIns="0" rtlCol="0" anchor="ctr"/>
+          <a:lstStyle/>
+          <a:p>
+            <a:pPr algn="ctr" indent="0" marL="0">
+              <a:buNone/>
+            </a:pPr>
+            <a:r>
+              <a:rPr lang="en-US" sz="650" b="1" dirty="0">
+                <a:solidFill>
+                  <a:srgbClr val="FFFFFF"/>
+                </a:solidFill>
+                <a:latin typeface="Helvetica Neue" pitchFamily="34" charset="0"/>
+                <a:ea typeface="Helvetica Neue" pitchFamily="34" charset="-122"/>
+                <a:cs typeface="Helvetica Neue" pitchFamily="34" charset="-120"/>
+              </a:rPr>
+              <a:t>OUTPUT</a:t>
+            </a:r>
+            <a:endParaRPr lang="en-US" sz="650" dirty="0"/>
+          </a:p>
+        </p:txBody>
+      </p:sp>
+      <p:sp>
+        <p:nvSpPr>
+          <p:cNvPr id="29" name="Text 27"/>
+          <p:cNvSpPr/>
+          <p:nvPr/>
+        </p:nvSpPr>
+        <p:spPr>
+          <a:xfrm>
+            <a:off x="969264" y="4837176"/>
+            <a:ext cx="3995928" cy="146304"/>
           </a:xfrm>
           <a:prstGeom prst="rect">
             <a:avLst/>
@@ -9376,30 +10112,30 @@
               <a:buNone/>
             </a:pPr>
             <a:r>
-              <a:rPr lang="en-US" sz="1700" b="1" dirty="0">
-                <a:solidFill>
-                  <a:srgbClr val="0F1B2E"/>
-                </a:solidFill>
-                <a:latin typeface="Helvetica Neue" pitchFamily="34" charset="0"/>
-                <a:ea typeface="Helvetica Neue" pitchFamily="34" charset="-122"/>
-                <a:cs typeface="Helvetica Neue" pitchFamily="34" charset="-120"/>
-              </a:rPr>
-              <a:t>Human + AI, at the component layer</a:t>
-            </a:r>
-            <a:endParaRPr lang="en-US" sz="1700" dirty="0"/>
-          </a:p>
-        </p:txBody>
-      </p:sp>
-      <p:sp>
-        <p:nvSpPr>
-          <p:cNvPr id="9" name="Text 7"/>
-          <p:cNvSpPr/>
-          <p:nvPr/>
-        </p:nvSpPr>
-        <p:spPr>
-          <a:xfrm>
-            <a:off x="886968" y="3611880"/>
-            <a:ext cx="4660240" cy="1463040"/>
+              <a:rPr lang="en-US" sz="920" dirty="0">
+                <a:solidFill>
+                  <a:srgbClr val="6B7C93"/>
+                </a:solidFill>
+                <a:latin typeface="Helvetica Neue" pitchFamily="34" charset="0"/>
+                <a:ea typeface="Helvetica Neue" pitchFamily="34" charset="-122"/>
+                <a:cs typeface="Helvetica Neue" pitchFamily="34" charset="-120"/>
+              </a:rPr>
+              <a:t>• Next step is implicit</a:t>
+            </a:r>
+            <a:endParaRPr lang="en-US" sz="920" dirty="0"/>
+          </a:p>
+        </p:txBody>
+      </p:sp>
+      <p:sp>
+        <p:nvSpPr>
+          <p:cNvPr id="30" name="Text 28"/>
+          <p:cNvSpPr/>
+          <p:nvPr/>
+        </p:nvSpPr>
+        <p:spPr>
+          <a:xfrm>
+            <a:off x="969264" y="5047488"/>
+            <a:ext cx="3995928" cy="146304"/>
           </a:xfrm>
           <a:prstGeom prst="rect">
             <a:avLst/>
@@ -9412,40 +10148,76 @@
           <a:lstStyle/>
           <a:p>
             <a:pPr indent="0" marL="0">
-              <a:lnSpc>
-                <a:spcPct val="130000"/>
-              </a:lnSpc>
-              <a:buNone/>
-            </a:pPr>
-            <a:r>
-              <a:rPr lang="en-US" sz="1350" dirty="0">
-                <a:solidFill>
-                  <a:srgbClr val="2A3A51"/>
-                </a:solidFill>
-                <a:latin typeface="Helvetica Neue" pitchFamily="34" charset="0"/>
-                <a:ea typeface="Helvetica Neue" pitchFamily="34" charset="-122"/>
-                <a:cs typeface="Helvetica Neue" pitchFamily="34" charset="-120"/>
-              </a:rPr>
-              <a:t>Components are self-contained units. People and agents both work on structure and merge at the component layer — no fighting over the same lines, no git text-conflicts.</a:t>
-            </a:r>
-            <a:endParaRPr lang="en-US" sz="1350" dirty="0"/>
-          </a:p>
-        </p:txBody>
-      </p:sp>
-      <p:sp>
-        <p:nvSpPr>
-          <p:cNvPr id="10" name="Shape 8"/>
-          <p:cNvSpPr/>
-          <p:nvPr/>
-        </p:nvSpPr>
-        <p:spPr>
-          <a:xfrm>
-            <a:off x="6324448" y="2560320"/>
-            <a:ext cx="5300320" cy="2743200"/>
+              <a:buNone/>
+            </a:pPr>
+            <a:r>
+              <a:rPr lang="en-US" sz="920" dirty="0">
+                <a:solidFill>
+                  <a:srgbClr val="6B7C93"/>
+                </a:solidFill>
+                <a:latin typeface="Helvetica Neue" pitchFamily="34" charset="0"/>
+                <a:ea typeface="Helvetica Neue" pitchFamily="34" charset="-122"/>
+                <a:cs typeface="Helvetica Neue" pitchFamily="34" charset="-120"/>
+              </a:rPr>
+              <a:t>• Operator skill dominates</a:t>
+            </a:r>
+            <a:endParaRPr lang="en-US" sz="920" dirty="0"/>
+          </a:p>
+        </p:txBody>
+      </p:sp>
+      <p:sp>
+        <p:nvSpPr>
+          <p:cNvPr id="31" name="Text 29"/>
+          <p:cNvSpPr/>
+          <p:nvPr/>
+        </p:nvSpPr>
+        <p:spPr>
+          <a:xfrm>
+            <a:off x="969264" y="5257800"/>
+            <a:ext cx="3995928" cy="146304"/>
+          </a:xfrm>
+          <a:prstGeom prst="rect">
+            <a:avLst/>
+          </a:prstGeom>
+          <a:noFill/>
+          <a:ln/>
+        </p:spPr>
+        <p:txBody>
+          <a:bodyPr wrap="square" lIns="0" tIns="0" rIns="0" bIns="0" rtlCol="0" anchor="ctr"/>
+          <a:lstStyle/>
+          <a:p>
+            <a:pPr indent="0" marL="0">
+              <a:buNone/>
+            </a:pPr>
+            <a:r>
+              <a:rPr lang="en-US" sz="920" dirty="0">
+                <a:solidFill>
+                  <a:srgbClr val="6B7C93"/>
+                </a:solidFill>
+                <a:latin typeface="Helvetica Neue" pitchFamily="34" charset="0"/>
+                <a:ea typeface="Helvetica Neue" pitchFamily="34" charset="-122"/>
+                <a:cs typeface="Helvetica Neue" pitchFamily="34" charset="-120"/>
+              </a:rPr>
+              <a:t>• Run-to-run output drifts</a:t>
+            </a:r>
+            <a:endParaRPr lang="en-US" sz="920" dirty="0"/>
+          </a:p>
+        </p:txBody>
+      </p:sp>
+      <p:sp>
+        <p:nvSpPr>
+          <p:cNvPr id="32" name="Shape 30"/>
+          <p:cNvSpPr/>
+          <p:nvPr/>
+        </p:nvSpPr>
+        <p:spPr>
+          <a:xfrm>
+            <a:off x="6035040" y="1874520"/>
+            <a:ext cx="5577840" cy="3611880"/>
           </a:xfrm>
           <a:prstGeom prst="roundRect">
             <a:avLst>
-              <a:gd name="adj" fmla="val 3000"/>
+              <a:gd name="adj" fmla="val 2278"/>
             </a:avLst>
           </a:prstGeom>
           <a:solidFill>
@@ -9463,92 +10235,1035 @@
       </p:sp>
       <p:sp>
         <p:nvSpPr>
-          <p:cNvPr id="11" name="Shape 9"/>
-          <p:cNvSpPr/>
-          <p:nvPr/>
-        </p:nvSpPr>
-        <p:spPr>
-          <a:xfrm>
-            <a:off x="6644488" y="2880360"/>
-            <a:ext cx="457200" cy="73152"/>
-          </a:xfrm>
-          <a:prstGeom prst="rect">
-            <a:avLst/>
+          <p:cNvPr id="33" name="Text 31"/>
+          <p:cNvSpPr/>
+          <p:nvPr/>
+        </p:nvSpPr>
+        <p:spPr>
+          <a:xfrm>
+            <a:off x="6345936" y="2130552"/>
+            <a:ext cx="1920240" cy="219456"/>
+          </a:xfrm>
+          <a:prstGeom prst="rect">
+            <a:avLst/>
+          </a:prstGeom>
+          <a:noFill/>
+          <a:ln/>
+        </p:spPr>
+        <p:txBody>
+          <a:bodyPr wrap="square" lIns="0" tIns="0" rIns="0" bIns="0" rtlCol="0" anchor="ctr"/>
+          <a:lstStyle/>
+          <a:p>
+            <a:pPr indent="0" marL="0">
+              <a:buNone/>
+            </a:pPr>
+            <a:r>
+              <a:rPr lang="en-US" sz="1500" b="1" dirty="0">
+                <a:solidFill>
+                  <a:srgbClr val="FFFFFF"/>
+                </a:solidFill>
+                <a:latin typeface="Helvetica Neue" pitchFamily="34" charset="0"/>
+                <a:ea typeface="Helvetica Neue" pitchFamily="34" charset="-122"/>
+                <a:cs typeface="Helvetica Neue" pitchFamily="34" charset="-120"/>
+              </a:rPr>
+              <a:t>DAG Harness</a:t>
+            </a:r>
+            <a:endParaRPr lang="en-US" sz="1500" dirty="0"/>
+          </a:p>
+        </p:txBody>
+      </p:sp>
+      <p:sp>
+        <p:nvSpPr>
+          <p:cNvPr id="34" name="Text 32"/>
+          <p:cNvSpPr/>
+          <p:nvPr/>
+        </p:nvSpPr>
+        <p:spPr>
+          <a:xfrm>
+            <a:off x="8046720" y="2157984"/>
+            <a:ext cx="3246120" cy="164592"/>
+          </a:xfrm>
+          <a:prstGeom prst="rect">
+            <a:avLst/>
+          </a:prstGeom>
+          <a:noFill/>
+          <a:ln/>
+        </p:spPr>
+        <p:txBody>
+          <a:bodyPr wrap="square" lIns="0" tIns="0" rIns="0" bIns="0" rtlCol="0" anchor="ctr"/>
+          <a:lstStyle/>
+          <a:p>
+            <a:pPr indent="0" marL="0">
+              <a:buNone/>
+            </a:pPr>
+            <a:r>
+              <a:rPr lang="en-US" sz="950" dirty="0">
+                <a:solidFill>
+                  <a:srgbClr val="9FB0C8"/>
+                </a:solidFill>
+                <a:latin typeface="Helvetica Neue" pitchFamily="34" charset="0"/>
+                <a:ea typeface="Helvetica Neue" pitchFamily="34" charset="-122"/>
+                <a:cs typeface="Helvetica Neue" pitchFamily="34" charset="-120"/>
+              </a:rPr>
+              <a:t>inputs, outputs, node types and checkpoints are explicit</a:t>
+            </a:r>
+            <a:endParaRPr lang="en-US" sz="950" dirty="0"/>
+          </a:p>
+        </p:txBody>
+      </p:sp>
+      <p:sp>
+        <p:nvSpPr>
+          <p:cNvPr id="35" name="Shape 33"/>
+          <p:cNvSpPr/>
+          <p:nvPr/>
+        </p:nvSpPr>
+        <p:spPr>
+          <a:xfrm>
+            <a:off x="6382512" y="2898648"/>
+            <a:ext cx="987552" cy="512064"/>
+          </a:xfrm>
+          <a:prstGeom prst="roundRect">
+            <a:avLst>
+              <a:gd name="adj" fmla="val 12500"/>
+            </a:avLst>
           </a:prstGeom>
           <a:solidFill>
-            <a:srgbClr val="7FE7DA"/>
+            <a:srgbClr val="102747"/>
           </a:solidFill>
-          <a:ln/>
-        </p:spPr>
-      </p:sp>
-      <p:sp>
-        <p:nvSpPr>
-          <p:cNvPr id="12" name="Text 10"/>
-          <p:cNvSpPr/>
-          <p:nvPr/>
-        </p:nvSpPr>
-        <p:spPr>
-          <a:xfrm>
-            <a:off x="6644488" y="3017520"/>
-            <a:ext cx="4660240" cy="502920"/>
-          </a:xfrm>
-          <a:prstGeom prst="rect">
-            <a:avLst/>
-          </a:prstGeom>
-          <a:noFill/>
-          <a:ln/>
-        </p:spPr>
-        <p:txBody>
-          <a:bodyPr wrap="square" lIns="0" tIns="0" rIns="0" bIns="0" rtlCol="0" anchor="ctr"/>
+          <a:ln w="12700">
+            <a:solidFill>
+              <a:srgbClr val="26405F"/>
+            </a:solidFill>
+            <a:prstDash val="solid"/>
+          </a:ln>
+        </p:spPr>
+      </p:sp>
+      <p:sp>
+        <p:nvSpPr>
+          <p:cNvPr id="36" name="Text 34"/>
+          <p:cNvSpPr/>
+          <p:nvPr/>
+        </p:nvSpPr>
+        <p:spPr>
+          <a:xfrm>
+            <a:off x="6455664" y="3026664"/>
+            <a:ext cx="841248" cy="109728"/>
+          </a:xfrm>
+          <a:prstGeom prst="rect">
+            <a:avLst/>
+          </a:prstGeom>
+          <a:noFill/>
+          <a:ln/>
+        </p:spPr>
+        <p:txBody>
+          <a:bodyPr wrap="square" lIns="0" tIns="0" rIns="0" bIns="0" rtlCol="0" anchor="ctr"/>
+          <a:lstStyle/>
+          <a:p>
+            <a:pPr algn="ctr" indent="0" marL="0">
+              <a:buNone/>
+            </a:pPr>
+            <a:r>
+              <a:rPr lang="en-US" sz="870" b="1" dirty="0">
+                <a:solidFill>
+                  <a:srgbClr val="FFFFFF"/>
+                </a:solidFill>
+                <a:latin typeface="Helvetica Neue" pitchFamily="34" charset="0"/>
+                <a:ea typeface="Helvetica Neue" pitchFamily="34" charset="-122"/>
+                <a:cs typeface="Helvetica Neue" pitchFamily="34" charset="-120"/>
+              </a:rPr>
+              <a:t>Intent</a:t>
+            </a:r>
+            <a:endParaRPr lang="en-US" sz="870" dirty="0"/>
+          </a:p>
+        </p:txBody>
+      </p:sp>
+      <p:sp>
+        <p:nvSpPr>
+          <p:cNvPr id="37" name="Text 35"/>
+          <p:cNvSpPr/>
+          <p:nvPr/>
+        </p:nvSpPr>
+        <p:spPr>
+          <a:xfrm>
+            <a:off x="6455664" y="3209544"/>
+            <a:ext cx="841248" cy="73152"/>
+          </a:xfrm>
+          <a:prstGeom prst="rect">
+            <a:avLst/>
+          </a:prstGeom>
+          <a:noFill/>
+          <a:ln/>
+        </p:spPr>
+        <p:txBody>
+          <a:bodyPr wrap="square" lIns="0" tIns="0" rIns="0" bIns="0" rtlCol="0" anchor="ctr"/>
+          <a:lstStyle/>
+          <a:p>
+            <a:pPr algn="ctr" indent="0" marL="0">
+              <a:buNone/>
+            </a:pPr>
+            <a:r>
+              <a:rPr lang="en-US" sz="670" dirty="0">
+                <a:solidFill>
+                  <a:srgbClr val="9FB0C8"/>
+                </a:solidFill>
+                <a:latin typeface="Helvetica Neue" pitchFamily="34" charset="0"/>
+                <a:ea typeface="Helvetica Neue" pitchFamily="34" charset="-122"/>
+                <a:cs typeface="Helvetica Neue" pitchFamily="34" charset="-120"/>
+              </a:rPr>
+              <a:t>input</a:t>
+            </a:r>
+            <a:endParaRPr lang="en-US" sz="670" dirty="0"/>
+          </a:p>
+        </p:txBody>
+      </p:sp>
+      <p:sp>
+        <p:nvSpPr>
+          <p:cNvPr id="38" name="Shape 36"/>
+          <p:cNvSpPr/>
+          <p:nvPr/>
+        </p:nvSpPr>
+        <p:spPr>
+          <a:xfrm>
+            <a:off x="7370064" y="3154680"/>
+            <a:ext cx="310896" cy="0"/>
+          </a:xfrm>
+          <a:prstGeom prst="line">
+            <a:avLst/>
+          </a:prstGeom>
+          <a:noFill/>
+          <a:ln w="15240">
+            <a:solidFill>
+              <a:srgbClr val="7FE7DA"/>
+            </a:solidFill>
+            <a:prstDash val="solid"/>
+            <a:tailEnd type="triangle"/>
+          </a:ln>
+        </p:spPr>
+      </p:sp>
+      <p:sp>
+        <p:nvSpPr>
+          <p:cNvPr id="39" name="Shape 37"/>
+          <p:cNvSpPr/>
+          <p:nvPr/>
+        </p:nvSpPr>
+        <p:spPr>
+          <a:xfrm>
+            <a:off x="7680960" y="2898648"/>
+            <a:ext cx="987552" cy="512064"/>
+          </a:xfrm>
+          <a:prstGeom prst="roundRect">
+            <a:avLst>
+              <a:gd name="adj" fmla="val 12500"/>
+            </a:avLst>
+          </a:prstGeom>
+          <a:solidFill>
+            <a:srgbClr val="15B3A4"/>
+          </a:solidFill>
+          <a:ln w="12700">
+            <a:solidFill>
+              <a:srgbClr val="15B3A4"/>
+            </a:solidFill>
+            <a:prstDash val="solid"/>
+          </a:ln>
+        </p:spPr>
+      </p:sp>
+      <p:sp>
+        <p:nvSpPr>
+          <p:cNvPr id="40" name="Text 38"/>
+          <p:cNvSpPr/>
+          <p:nvPr/>
+        </p:nvSpPr>
+        <p:spPr>
+          <a:xfrm>
+            <a:off x="7754112" y="3026664"/>
+            <a:ext cx="841248" cy="109728"/>
+          </a:xfrm>
+          <a:prstGeom prst="rect">
+            <a:avLst/>
+          </a:prstGeom>
+          <a:noFill/>
+          <a:ln/>
+        </p:spPr>
+        <p:txBody>
+          <a:bodyPr wrap="square" lIns="0" tIns="0" rIns="0" bIns="0" rtlCol="0" anchor="ctr"/>
+          <a:lstStyle/>
+          <a:p>
+            <a:pPr algn="ctr" indent="0" marL="0">
+              <a:buNone/>
+            </a:pPr>
+            <a:r>
+              <a:rPr lang="en-US" sz="870" b="1" dirty="0">
+                <a:solidFill>
+                  <a:srgbClr val="04211D"/>
+                </a:solidFill>
+                <a:latin typeface="Helvetica Neue" pitchFamily="34" charset="0"/>
+                <a:ea typeface="Helvetica Neue" pitchFamily="34" charset="-122"/>
+                <a:cs typeface="Helvetica Neue" pitchFamily="34" charset="-120"/>
+              </a:rPr>
+              <a:t>Plan</a:t>
+            </a:r>
+            <a:endParaRPr lang="en-US" sz="870" dirty="0"/>
+          </a:p>
+        </p:txBody>
+      </p:sp>
+      <p:sp>
+        <p:nvSpPr>
+          <p:cNvPr id="41" name="Text 39"/>
+          <p:cNvSpPr/>
+          <p:nvPr/>
+        </p:nvSpPr>
+        <p:spPr>
+          <a:xfrm>
+            <a:off x="7754112" y="3209544"/>
+            <a:ext cx="841248" cy="73152"/>
+          </a:xfrm>
+          <a:prstGeom prst="rect">
+            <a:avLst/>
+          </a:prstGeom>
+          <a:noFill/>
+          <a:ln/>
+        </p:spPr>
+        <p:txBody>
+          <a:bodyPr wrap="square" lIns="0" tIns="0" rIns="0" bIns="0" rtlCol="0" anchor="ctr"/>
+          <a:lstStyle/>
+          <a:p>
+            <a:pPr algn="ctr" indent="0" marL="0">
+              <a:buNone/>
+            </a:pPr>
+            <a:r>
+              <a:rPr lang="en-US" sz="670" dirty="0">
+                <a:solidFill>
+                  <a:srgbClr val="06443D"/>
+                </a:solidFill>
+                <a:latin typeface="Helvetica Neue" pitchFamily="34" charset="0"/>
+                <a:ea typeface="Helvetica Neue" pitchFamily="34" charset="-122"/>
+                <a:cs typeface="Helvetica Neue" pitchFamily="34" charset="-120"/>
+              </a:rPr>
+              <a:t>AI</a:t>
+            </a:r>
+            <a:endParaRPr lang="en-US" sz="670" dirty="0"/>
+          </a:p>
+        </p:txBody>
+      </p:sp>
+      <p:sp>
+        <p:nvSpPr>
+          <p:cNvPr id="42" name="Shape 40"/>
+          <p:cNvSpPr/>
+          <p:nvPr/>
+        </p:nvSpPr>
+        <p:spPr>
+          <a:xfrm>
+            <a:off x="8668512" y="3154680"/>
+            <a:ext cx="310896" cy="0"/>
+          </a:xfrm>
+          <a:prstGeom prst="line">
+            <a:avLst/>
+          </a:prstGeom>
+          <a:noFill/>
+          <a:ln w="15240">
+            <a:solidFill>
+              <a:srgbClr val="7FE7DA"/>
+            </a:solidFill>
+            <a:prstDash val="solid"/>
+            <a:tailEnd type="triangle"/>
+          </a:ln>
+        </p:spPr>
+      </p:sp>
+      <p:sp>
+        <p:nvSpPr>
+          <p:cNvPr id="43" name="Shape 41"/>
+          <p:cNvSpPr/>
+          <p:nvPr/>
+        </p:nvSpPr>
+        <p:spPr>
+          <a:xfrm>
+            <a:off x="8979408" y="2898648"/>
+            <a:ext cx="987552" cy="512064"/>
+          </a:xfrm>
+          <a:prstGeom prst="roundRect">
+            <a:avLst>
+              <a:gd name="adj" fmla="val 12500"/>
+            </a:avLst>
+          </a:prstGeom>
+          <a:solidFill>
+            <a:srgbClr val="102747"/>
+          </a:solidFill>
+          <a:ln w="12700">
+            <a:solidFill>
+              <a:srgbClr val="26405F"/>
+            </a:solidFill>
+            <a:prstDash val="solid"/>
+          </a:ln>
+        </p:spPr>
+      </p:sp>
+      <p:sp>
+        <p:nvSpPr>
+          <p:cNvPr id="44" name="Text 42"/>
+          <p:cNvSpPr/>
+          <p:nvPr/>
+        </p:nvSpPr>
+        <p:spPr>
+          <a:xfrm>
+            <a:off x="9052560" y="3026664"/>
+            <a:ext cx="841248" cy="109728"/>
+          </a:xfrm>
+          <a:prstGeom prst="rect">
+            <a:avLst/>
+          </a:prstGeom>
+          <a:noFill/>
+          <a:ln/>
+        </p:spPr>
+        <p:txBody>
+          <a:bodyPr wrap="square" lIns="0" tIns="0" rIns="0" bIns="0" rtlCol="0" anchor="ctr"/>
+          <a:lstStyle/>
+          <a:p>
+            <a:pPr algn="ctr" indent="0" marL="0">
+              <a:buNone/>
+            </a:pPr>
+            <a:r>
+              <a:rPr lang="en-US" sz="870" b="1" dirty="0">
+                <a:solidFill>
+                  <a:srgbClr val="FFFFFF"/>
+                </a:solidFill>
+                <a:latin typeface="Helvetica Neue" pitchFamily="34" charset="0"/>
+                <a:ea typeface="Helvetica Neue" pitchFamily="34" charset="-122"/>
+                <a:cs typeface="Helvetica Neue" pitchFamily="34" charset="-120"/>
+              </a:rPr>
+              <a:t>Contract</a:t>
+            </a:r>
+            <a:endParaRPr lang="en-US" sz="870" dirty="0"/>
+          </a:p>
+        </p:txBody>
+      </p:sp>
+      <p:sp>
+        <p:nvSpPr>
+          <p:cNvPr id="45" name="Text 43"/>
+          <p:cNvSpPr/>
+          <p:nvPr/>
+        </p:nvSpPr>
+        <p:spPr>
+          <a:xfrm>
+            <a:off x="9052560" y="3209544"/>
+            <a:ext cx="841248" cy="73152"/>
+          </a:xfrm>
+          <a:prstGeom prst="rect">
+            <a:avLst/>
+          </a:prstGeom>
+          <a:noFill/>
+          <a:ln/>
+        </p:spPr>
+        <p:txBody>
+          <a:bodyPr wrap="square" lIns="0" tIns="0" rIns="0" bIns="0" rtlCol="0" anchor="ctr"/>
+          <a:lstStyle/>
+          <a:p>
+            <a:pPr algn="ctr" indent="0" marL="0">
+              <a:buNone/>
+            </a:pPr>
+            <a:r>
+              <a:rPr lang="en-US" sz="670" dirty="0">
+                <a:solidFill>
+                  <a:srgbClr val="9FB0C8"/>
+                </a:solidFill>
+                <a:latin typeface="Helvetica Neue" pitchFamily="34" charset="0"/>
+                <a:ea typeface="Helvetica Neue" pitchFamily="34" charset="-122"/>
+                <a:cs typeface="Helvetica Neue" pitchFamily="34" charset="-120"/>
+              </a:rPr>
+              <a:t>manifest</a:t>
+            </a:r>
+            <a:endParaRPr lang="en-US" sz="670" dirty="0"/>
+          </a:p>
+        </p:txBody>
+      </p:sp>
+      <p:sp>
+        <p:nvSpPr>
+          <p:cNvPr id="46" name="Shape 44"/>
+          <p:cNvSpPr/>
+          <p:nvPr/>
+        </p:nvSpPr>
+        <p:spPr>
+          <a:xfrm>
+            <a:off x="9966960" y="3154680"/>
+            <a:ext cx="310896" cy="0"/>
+          </a:xfrm>
+          <a:prstGeom prst="line">
+            <a:avLst/>
+          </a:prstGeom>
+          <a:noFill/>
+          <a:ln w="15240">
+            <a:solidFill>
+              <a:srgbClr val="7FE7DA"/>
+            </a:solidFill>
+            <a:prstDash val="solid"/>
+            <a:tailEnd type="triangle"/>
+          </a:ln>
+        </p:spPr>
+      </p:sp>
+      <p:sp>
+        <p:nvSpPr>
+          <p:cNvPr id="47" name="Shape 45"/>
+          <p:cNvSpPr/>
+          <p:nvPr/>
+        </p:nvSpPr>
+        <p:spPr>
+          <a:xfrm>
+            <a:off x="10277856" y="2898648"/>
+            <a:ext cx="987552" cy="512064"/>
+          </a:xfrm>
+          <a:prstGeom prst="roundRect">
+            <a:avLst>
+              <a:gd name="adj" fmla="val 12500"/>
+            </a:avLst>
+          </a:prstGeom>
+          <a:solidFill>
+            <a:srgbClr val="15B3A4"/>
+          </a:solidFill>
+          <a:ln w="12700">
+            <a:solidFill>
+              <a:srgbClr val="15B3A4"/>
+            </a:solidFill>
+            <a:prstDash val="solid"/>
+          </a:ln>
+        </p:spPr>
+      </p:sp>
+      <p:sp>
+        <p:nvSpPr>
+          <p:cNvPr id="48" name="Text 46"/>
+          <p:cNvSpPr/>
+          <p:nvPr/>
+        </p:nvSpPr>
+        <p:spPr>
+          <a:xfrm>
+            <a:off x="10351008" y="3026664"/>
+            <a:ext cx="841248" cy="109728"/>
+          </a:xfrm>
+          <a:prstGeom prst="rect">
+            <a:avLst/>
+          </a:prstGeom>
+          <a:noFill/>
+          <a:ln/>
+        </p:spPr>
+        <p:txBody>
+          <a:bodyPr wrap="square" lIns="0" tIns="0" rIns="0" bIns="0" rtlCol="0" anchor="ctr"/>
+          <a:lstStyle/>
+          <a:p>
+            <a:pPr algn="ctr" indent="0" marL="0">
+              <a:buNone/>
+            </a:pPr>
+            <a:r>
+              <a:rPr lang="en-US" sz="870" b="1" dirty="0">
+                <a:solidFill>
+                  <a:srgbClr val="04211D"/>
+                </a:solidFill>
+                <a:latin typeface="Helvetica Neue" pitchFamily="34" charset="0"/>
+                <a:ea typeface="Helvetica Neue" pitchFamily="34" charset="-122"/>
+                <a:cs typeface="Helvetica Neue" pitchFamily="34" charset="-120"/>
+              </a:rPr>
+              <a:t>Build</a:t>
+            </a:r>
+            <a:endParaRPr lang="en-US" sz="870" dirty="0"/>
+          </a:p>
+        </p:txBody>
+      </p:sp>
+      <p:sp>
+        <p:nvSpPr>
+          <p:cNvPr id="49" name="Text 47"/>
+          <p:cNvSpPr/>
+          <p:nvPr/>
+        </p:nvSpPr>
+        <p:spPr>
+          <a:xfrm>
+            <a:off x="10351008" y="3209544"/>
+            <a:ext cx="841248" cy="73152"/>
+          </a:xfrm>
+          <a:prstGeom prst="rect">
+            <a:avLst/>
+          </a:prstGeom>
+          <a:noFill/>
+          <a:ln/>
+        </p:spPr>
+        <p:txBody>
+          <a:bodyPr wrap="square" lIns="0" tIns="0" rIns="0" bIns="0" rtlCol="0" anchor="ctr"/>
+          <a:lstStyle/>
+          <a:p>
+            <a:pPr algn="ctr" indent="0" marL="0">
+              <a:buNone/>
+            </a:pPr>
+            <a:r>
+              <a:rPr lang="en-US" sz="670" dirty="0">
+                <a:solidFill>
+                  <a:srgbClr val="06443D"/>
+                </a:solidFill>
+                <a:latin typeface="Helvetica Neue" pitchFamily="34" charset="0"/>
+                <a:ea typeface="Helvetica Neue" pitchFamily="34" charset="-122"/>
+                <a:cs typeface="Helvetica Neue" pitchFamily="34" charset="-120"/>
+              </a:rPr>
+              <a:t>AI/tool</a:t>
+            </a:r>
+            <a:endParaRPr lang="en-US" sz="670" dirty="0"/>
+          </a:p>
+        </p:txBody>
+      </p:sp>
+      <p:sp>
+        <p:nvSpPr>
+          <p:cNvPr id="50" name="Shape 48"/>
+          <p:cNvSpPr/>
+          <p:nvPr/>
+        </p:nvSpPr>
+        <p:spPr>
+          <a:xfrm>
+            <a:off x="10771632" y="3410712"/>
+            <a:ext cx="0" cy="310896"/>
+          </a:xfrm>
+          <a:prstGeom prst="line">
+            <a:avLst/>
+          </a:prstGeom>
+          <a:noFill/>
+          <a:ln w="15240">
+            <a:solidFill>
+              <a:srgbClr val="7FE7DA"/>
+            </a:solidFill>
+            <a:prstDash val="solid"/>
+          </a:ln>
+        </p:spPr>
+      </p:sp>
+      <p:sp>
+        <p:nvSpPr>
+          <p:cNvPr id="51" name="Shape 49"/>
+          <p:cNvSpPr/>
+          <p:nvPr/>
+        </p:nvSpPr>
+        <p:spPr>
+          <a:xfrm>
+            <a:off x="6876288" y="3721608"/>
+            <a:ext cx="3895344" cy="0"/>
+          </a:xfrm>
+          <a:prstGeom prst="line">
+            <a:avLst/>
+          </a:prstGeom>
+          <a:noFill/>
+          <a:ln w="15240">
+            <a:solidFill>
+              <a:srgbClr val="7FE7DA"/>
+            </a:solidFill>
+            <a:prstDash val="solid"/>
+          </a:ln>
+        </p:spPr>
+      </p:sp>
+      <p:sp>
+        <p:nvSpPr>
+          <p:cNvPr id="52" name="Shape 50"/>
+          <p:cNvSpPr/>
+          <p:nvPr/>
+        </p:nvSpPr>
+        <p:spPr>
+          <a:xfrm>
+            <a:off x="6876288" y="3721608"/>
+            <a:ext cx="0" cy="310896"/>
+          </a:xfrm>
+          <a:prstGeom prst="line">
+            <a:avLst/>
+          </a:prstGeom>
+          <a:noFill/>
+          <a:ln w="15240">
+            <a:solidFill>
+              <a:srgbClr val="7FE7DA"/>
+            </a:solidFill>
+            <a:prstDash val="solid"/>
+            <a:tailEnd type="triangle"/>
+          </a:ln>
+        </p:spPr>
+      </p:sp>
+      <p:sp>
+        <p:nvSpPr>
+          <p:cNvPr id="53" name="Shape 51"/>
+          <p:cNvSpPr/>
+          <p:nvPr/>
+        </p:nvSpPr>
+        <p:spPr>
+          <a:xfrm>
+            <a:off x="6382512" y="4041648"/>
+            <a:ext cx="987552" cy="512064"/>
+          </a:xfrm>
+          <a:prstGeom prst="roundRect">
+            <a:avLst>
+              <a:gd name="adj" fmla="val 12500"/>
+            </a:avLst>
+          </a:prstGeom>
+          <a:solidFill>
+            <a:srgbClr val="102747"/>
+          </a:solidFill>
+          <a:ln w="12700">
+            <a:solidFill>
+              <a:srgbClr val="26405F"/>
+            </a:solidFill>
+            <a:prstDash val="solid"/>
+          </a:ln>
+        </p:spPr>
+      </p:sp>
+      <p:sp>
+        <p:nvSpPr>
+          <p:cNvPr id="54" name="Text 52"/>
+          <p:cNvSpPr/>
+          <p:nvPr/>
+        </p:nvSpPr>
+        <p:spPr>
+          <a:xfrm>
+            <a:off x="6455664" y="4169664"/>
+            <a:ext cx="841248" cy="109728"/>
+          </a:xfrm>
+          <a:prstGeom prst="rect">
+            <a:avLst/>
+          </a:prstGeom>
+          <a:noFill/>
+          <a:ln/>
+        </p:spPr>
+        <p:txBody>
+          <a:bodyPr wrap="square" lIns="0" tIns="0" rIns="0" bIns="0" rtlCol="0" anchor="ctr"/>
+          <a:lstStyle/>
+          <a:p>
+            <a:pPr algn="ctr" indent="0" marL="0">
+              <a:buNone/>
+            </a:pPr>
+            <a:r>
+              <a:rPr lang="en-US" sz="870" b="1" dirty="0">
+                <a:solidFill>
+                  <a:srgbClr val="FFFFFF"/>
+                </a:solidFill>
+                <a:latin typeface="Helvetica Neue" pitchFamily="34" charset="0"/>
+                <a:ea typeface="Helvetica Neue" pitchFamily="34" charset="-122"/>
+                <a:cs typeface="Helvetica Neue" pitchFamily="34" charset="-120"/>
+              </a:rPr>
+              <a:t>Check</a:t>
+            </a:r>
+            <a:endParaRPr lang="en-US" sz="870" dirty="0"/>
+          </a:p>
+        </p:txBody>
+      </p:sp>
+      <p:sp>
+        <p:nvSpPr>
+          <p:cNvPr id="55" name="Text 53"/>
+          <p:cNvSpPr/>
+          <p:nvPr/>
+        </p:nvSpPr>
+        <p:spPr>
+          <a:xfrm>
+            <a:off x="6455664" y="4352544"/>
+            <a:ext cx="841248" cy="73152"/>
+          </a:xfrm>
+          <a:prstGeom prst="rect">
+            <a:avLst/>
+          </a:prstGeom>
+          <a:noFill/>
+          <a:ln/>
+        </p:spPr>
+        <p:txBody>
+          <a:bodyPr wrap="square" lIns="0" tIns="0" rIns="0" bIns="0" rtlCol="0" anchor="ctr"/>
+          <a:lstStyle/>
+          <a:p>
+            <a:pPr algn="ctr" indent="0" marL="0">
+              <a:buNone/>
+            </a:pPr>
+            <a:r>
+              <a:rPr lang="en-US" sz="670" dirty="0">
+                <a:solidFill>
+                  <a:srgbClr val="9FB0C8"/>
+                </a:solidFill>
+                <a:latin typeface="Helvetica Neue" pitchFamily="34" charset="0"/>
+                <a:ea typeface="Helvetica Neue" pitchFamily="34" charset="-122"/>
+                <a:cs typeface="Helvetica Neue" pitchFamily="34" charset="-120"/>
+              </a:rPr>
+              <a:t>lint</a:t>
+            </a:r>
+            <a:endParaRPr lang="en-US" sz="670" dirty="0"/>
+          </a:p>
+        </p:txBody>
+      </p:sp>
+      <p:sp>
+        <p:nvSpPr>
+          <p:cNvPr id="56" name="Shape 54"/>
+          <p:cNvSpPr/>
+          <p:nvPr/>
+        </p:nvSpPr>
+        <p:spPr>
+          <a:xfrm>
+            <a:off x="7370064" y="4297680"/>
+            <a:ext cx="310896" cy="0"/>
+          </a:xfrm>
+          <a:prstGeom prst="line">
+            <a:avLst/>
+          </a:prstGeom>
+          <a:noFill/>
+          <a:ln w="15240">
+            <a:solidFill>
+              <a:srgbClr val="7FE7DA"/>
+            </a:solidFill>
+            <a:prstDash val="solid"/>
+            <a:tailEnd type="triangle"/>
+          </a:ln>
+        </p:spPr>
+      </p:sp>
+      <p:sp>
+        <p:nvSpPr>
+          <p:cNvPr id="57" name="Shape 55"/>
+          <p:cNvSpPr/>
+          <p:nvPr/>
+        </p:nvSpPr>
+        <p:spPr>
+          <a:xfrm>
+            <a:off x="7680960" y="4041648"/>
+            <a:ext cx="987552" cy="512064"/>
+          </a:xfrm>
+          <a:prstGeom prst="roundRect">
+            <a:avLst>
+              <a:gd name="adj" fmla="val 12500"/>
+            </a:avLst>
+          </a:prstGeom>
+          <a:solidFill>
+            <a:srgbClr val="15B3A4"/>
+          </a:solidFill>
+          <a:ln w="12700">
+            <a:solidFill>
+              <a:srgbClr val="15B3A4"/>
+            </a:solidFill>
+            <a:prstDash val="solid"/>
+          </a:ln>
+        </p:spPr>
+      </p:sp>
+      <p:sp>
+        <p:nvSpPr>
+          <p:cNvPr id="58" name="Text 56"/>
+          <p:cNvSpPr/>
+          <p:nvPr/>
+        </p:nvSpPr>
+        <p:spPr>
+          <a:xfrm>
+            <a:off x="7754112" y="4169664"/>
+            <a:ext cx="841248" cy="109728"/>
+          </a:xfrm>
+          <a:prstGeom prst="rect">
+            <a:avLst/>
+          </a:prstGeom>
+          <a:noFill/>
+          <a:ln/>
+        </p:spPr>
+        <p:txBody>
+          <a:bodyPr wrap="square" lIns="0" tIns="0" rIns="0" bIns="0" rtlCol="0" anchor="ctr"/>
+          <a:lstStyle/>
+          <a:p>
+            <a:pPr algn="ctr" indent="0" marL="0">
+              <a:buNone/>
+            </a:pPr>
+            <a:r>
+              <a:rPr lang="en-US" sz="870" b="1" dirty="0">
+                <a:solidFill>
+                  <a:srgbClr val="04211D"/>
+                </a:solidFill>
+                <a:latin typeface="Helvetica Neue" pitchFamily="34" charset="0"/>
+                <a:ea typeface="Helvetica Neue" pitchFamily="34" charset="-122"/>
+                <a:cs typeface="Helvetica Neue" pitchFamily="34" charset="-120"/>
+              </a:rPr>
+              <a:t>Repair</a:t>
+            </a:r>
+            <a:endParaRPr lang="en-US" sz="870" dirty="0"/>
+          </a:p>
+        </p:txBody>
+      </p:sp>
+      <p:sp>
+        <p:nvSpPr>
+          <p:cNvPr id="59" name="Text 57"/>
+          <p:cNvSpPr/>
+          <p:nvPr/>
+        </p:nvSpPr>
+        <p:spPr>
+          <a:xfrm>
+            <a:off x="7754112" y="4352544"/>
+            <a:ext cx="841248" cy="73152"/>
+          </a:xfrm>
+          <a:prstGeom prst="rect">
+            <a:avLst/>
+          </a:prstGeom>
+          <a:noFill/>
+          <a:ln/>
+        </p:spPr>
+        <p:txBody>
+          <a:bodyPr wrap="square" lIns="0" tIns="0" rIns="0" bIns="0" rtlCol="0" anchor="ctr"/>
+          <a:lstStyle/>
+          <a:p>
+            <a:pPr algn="ctr" indent="0" marL="0">
+              <a:buNone/>
+            </a:pPr>
+            <a:r>
+              <a:rPr lang="en-US" sz="670" dirty="0">
+                <a:solidFill>
+                  <a:srgbClr val="06443D"/>
+                </a:solidFill>
+                <a:latin typeface="Helvetica Neue" pitchFamily="34" charset="0"/>
+                <a:ea typeface="Helvetica Neue" pitchFamily="34" charset="-122"/>
+                <a:cs typeface="Helvetica Neue" pitchFamily="34" charset="-120"/>
+              </a:rPr>
+              <a:t>AI</a:t>
+            </a:r>
+            <a:endParaRPr lang="en-US" sz="670" dirty="0"/>
+          </a:p>
+        </p:txBody>
+      </p:sp>
+      <p:sp>
+        <p:nvSpPr>
+          <p:cNvPr id="60" name="Shape 58"/>
+          <p:cNvSpPr/>
+          <p:nvPr/>
+        </p:nvSpPr>
+        <p:spPr>
+          <a:xfrm>
+            <a:off x="8668512" y="4297680"/>
+            <a:ext cx="310896" cy="0"/>
+          </a:xfrm>
+          <a:prstGeom prst="line">
+            <a:avLst/>
+          </a:prstGeom>
+          <a:noFill/>
+          <a:ln w="15240">
+            <a:solidFill>
+              <a:srgbClr val="7FE7DA"/>
+            </a:solidFill>
+            <a:prstDash val="solid"/>
+            <a:tailEnd type="triangle"/>
+          </a:ln>
+        </p:spPr>
+      </p:sp>
+      <p:sp>
+        <p:nvSpPr>
+          <p:cNvPr id="61" name="Shape 59"/>
+          <p:cNvSpPr/>
+          <p:nvPr/>
+        </p:nvSpPr>
+        <p:spPr>
+          <a:xfrm>
+            <a:off x="8979408" y="4041648"/>
+            <a:ext cx="987552" cy="512064"/>
+          </a:xfrm>
+          <a:prstGeom prst="roundRect">
+            <a:avLst>
+              <a:gd name="adj" fmla="val 12500"/>
+            </a:avLst>
+          </a:prstGeom>
+          <a:solidFill>
+            <a:srgbClr val="102747"/>
+          </a:solidFill>
+          <a:ln w="12700">
+            <a:solidFill>
+              <a:srgbClr val="26405F"/>
+            </a:solidFill>
+            <a:prstDash val="solid"/>
+          </a:ln>
+        </p:spPr>
+      </p:sp>
+      <p:sp>
+        <p:nvSpPr>
+          <p:cNvPr id="62" name="Text 60"/>
+          <p:cNvSpPr/>
+          <p:nvPr/>
+        </p:nvSpPr>
+        <p:spPr>
+          <a:xfrm>
+            <a:off x="9052560" y="4169664"/>
+            <a:ext cx="841248" cy="109728"/>
+          </a:xfrm>
+          <a:prstGeom prst="rect">
+            <a:avLst/>
+          </a:prstGeom>
+          <a:noFill/>
+          <a:ln/>
+        </p:spPr>
+        <p:txBody>
+          <a:bodyPr wrap="square" lIns="0" tIns="0" rIns="0" bIns="0" rtlCol="0" anchor="ctr"/>
+          <a:lstStyle/>
+          <a:p>
+            <a:pPr algn="ctr" indent="0" marL="0">
+              <a:buNone/>
+            </a:pPr>
+            <a:r>
+              <a:rPr lang="en-US" sz="870" b="1" dirty="0">
+                <a:solidFill>
+                  <a:srgbClr val="FFFFFF"/>
+                </a:solidFill>
+                <a:latin typeface="Helvetica Neue" pitchFamily="34" charset="0"/>
+                <a:ea typeface="Helvetica Neue" pitchFamily="34" charset="-122"/>
+                <a:cs typeface="Helvetica Neue" pitchFamily="34" charset="-120"/>
+              </a:rPr>
+              <a:t>Preview</a:t>
+            </a:r>
+            <a:endParaRPr lang="en-US" sz="870" dirty="0"/>
+          </a:p>
+        </p:txBody>
+      </p:sp>
+      <p:sp>
+        <p:nvSpPr>
+          <p:cNvPr id="63" name="Text 61"/>
+          <p:cNvSpPr/>
+          <p:nvPr/>
+        </p:nvSpPr>
+        <p:spPr>
+          <a:xfrm>
+            <a:off x="9052560" y="4352544"/>
+            <a:ext cx="841248" cy="73152"/>
+          </a:xfrm>
+          <a:prstGeom prst="rect">
+            <a:avLst/>
+          </a:prstGeom>
+          <a:noFill/>
+          <a:ln/>
+        </p:spPr>
+        <p:txBody>
+          <a:bodyPr wrap="square" lIns="0" tIns="0" rIns="0" bIns="0" rtlCol="0" anchor="ctr"/>
+          <a:lstStyle/>
+          <a:p>
+            <a:pPr algn="ctr" indent="0" marL="0">
+              <a:buNone/>
+            </a:pPr>
+            <a:r>
+              <a:rPr lang="en-US" sz="670" dirty="0">
+                <a:solidFill>
+                  <a:srgbClr val="9FB0C8"/>
+                </a:solidFill>
+                <a:latin typeface="Helvetica Neue" pitchFamily="34" charset="0"/>
+                <a:ea typeface="Helvetica Neue" pitchFamily="34" charset="-122"/>
+                <a:cs typeface="Helvetica Neue" pitchFamily="34" charset="-120"/>
+              </a:rPr>
+              <a:t>output</a:t>
+            </a:r>
+            <a:endParaRPr lang="en-US" sz="670" dirty="0"/>
+          </a:p>
+        </p:txBody>
+      </p:sp>
+      <p:sp>
+        <p:nvSpPr>
+          <p:cNvPr id="64" name="Text 62"/>
+          <p:cNvSpPr/>
+          <p:nvPr/>
+        </p:nvSpPr>
+        <p:spPr>
+          <a:xfrm>
+            <a:off x="6419088" y="4873752"/>
+            <a:ext cx="4809744" cy="384048"/>
+          </a:xfrm>
+          <a:prstGeom prst="rect">
+            <a:avLst/>
+          </a:prstGeom>
+          <a:noFill/>
+          <a:ln/>
+        </p:spPr>
+        <p:txBody>
+          <a:bodyPr wrap="square" lIns="0" tIns="0" rIns="0" bIns="0" rtlCol="0" anchor="ctr">
+            <a:normAutofit/>
+          </a:bodyPr>
           <a:lstStyle/>
           <a:p>
             <a:pPr indent="0" marL="0">
               <a:buNone/>
             </a:pPr>
             <a:r>
-              <a:rPr lang="en-US" sz="1700" b="1" dirty="0">
-                <a:solidFill>
-                  <a:srgbClr val="FFFFFF"/>
-                </a:solidFill>
-                <a:latin typeface="Helvetica Neue" pitchFamily="34" charset="0"/>
-                <a:ea typeface="Helvetica Neue" pitchFamily="34" charset="-122"/>
-                <a:cs typeface="Helvetica Neue" pitchFamily="34" charset="-120"/>
-              </a:rPr>
-              <a:t>The right model for every node</a:t>
-            </a:r>
-            <a:endParaRPr lang="en-US" sz="1700" dirty="0"/>
-          </a:p>
-        </p:txBody>
-      </p:sp>
-      <p:sp>
-        <p:nvSpPr>
-          <p:cNvPr id="13" name="Text 11"/>
-          <p:cNvSpPr/>
-          <p:nvPr/>
-        </p:nvSpPr>
-        <p:spPr>
-          <a:xfrm>
-            <a:off x="6644488" y="3611880"/>
-            <a:ext cx="4660240" cy="1463040"/>
-          </a:xfrm>
-          <a:prstGeom prst="rect">
-            <a:avLst/>
-          </a:prstGeom>
-          <a:noFill/>
-          <a:ln/>
-        </p:spPr>
-        <p:txBody>
-          <a:bodyPr wrap="square" lIns="0" tIns="0" rIns="0" bIns="0" rtlCol="0" anchor="ctr"/>
-          <a:lstStyle/>
-          <a:p>
-            <a:pPr indent="0" marL="0">
-              <a:lnSpc>
-                <a:spcPct val="130000"/>
-              </a:lnSpc>
-              <a:buNone/>
-            </a:pPr>
-            <a:r>
-              <a:rPr lang="en-US" sz="1350" dirty="0">
+              <a:rPr lang="en-US" sz="1050" dirty="0">
                 <a:solidFill>
                   <a:srgbClr val="9FB0C8"/>
                 </a:solidFill>
@@ -9556,15 +11271,15 @@
                 <a:ea typeface="Helvetica Neue" pitchFamily="34" charset="-122"/>
                 <a:cs typeface="Helvetica Neue" pitchFamily="34" charset="-120"/>
               </a:rPr>
-              <a:t>Route expensive models to the hard nodes and cheap models or tools to the routine ones. Capability where it counts, savings everywhere else.</a:t>
-            </a:r>
-            <a:endParaRPr lang="en-US" sz="1350" dirty="0"/>
-          </a:p>
-        </p:txBody>
-      </p:sp>
-      <p:sp>
-        <p:nvSpPr>
-          <p:cNvPr id="14" name="Shape 12"/>
+              <a:t>A DAG makes the AI process programmable: each node knows what to receive, what to produce, how to validate, and where the next step begins.</a:t>
+            </a:r>
+            <a:endParaRPr lang="en-US" sz="1050" dirty="0"/>
+          </a:p>
+        </p:txBody>
+      </p:sp>
+      <p:sp>
+        <p:nvSpPr>
+          <p:cNvPr id="65" name="Shape 63"/>
           <p:cNvSpPr/>
           <p:nvPr/>
         </p:nvSpPr>
@@ -9587,7 +11302,7 @@
       </p:sp>
       <p:sp>
         <p:nvSpPr>
-          <p:cNvPr id="15" name="Text 13"/>
+          <p:cNvPr id="66" name="Text 64"/>
           <p:cNvSpPr/>
           <p:nvPr/>
         </p:nvSpPr>
@@ -9640,7 +11355,7 @@
       </p:sp>
       <p:sp>
         <p:nvSpPr>
-          <p:cNvPr id="16" name="Text 14"/>
+          <p:cNvPr id="67" name="Text 65"/>
           <p:cNvSpPr/>
           <p:nvPr/>
         </p:nvSpPr>
@@ -9764,7 +11479,7 @@
                 <a:ea typeface="Helvetica Neue" pitchFamily="34" charset="-122"/>
                 <a:cs typeface="Helvetica Neue" pitchFamily="34" charset="-120"/>
               </a:rPr>
-              <a:t>17</a:t>
+              <a:t>16</a:t>
             </a:r>
             <a:endParaRPr lang="en-US" sz="1300" dirty="0"/>
           </a:p>
@@ -9803,7 +11518,7 @@
                 <a:ea typeface="Helvetica Neue" pitchFamily="34" charset="-122"/>
                 <a:cs typeface="Helvetica Neue" pitchFamily="34" charset="-120"/>
               </a:rPr>
-              <a:t>YOUR WAY</a:t>
+              <a:t>TEAM + COST</a:t>
             </a:r>
             <a:endParaRPr lang="en-US" sz="1150" dirty="0"/>
           </a:p>
@@ -9845,7 +11560,7 @@
                 <a:ea typeface="Helvetica Neue" pitchFamily="34" charset="-122"/>
                 <a:cs typeface="Helvetica Neue" pitchFamily="34" charset="-120"/>
               </a:rPr>
-              <a:t>Local-first. Cloud optional. </a:t>
+              <a:t>Collaborate without </a:t>
             </a:r>
             <a:pPr algn="l" indent="0" marL="0">
               <a:lnSpc>
@@ -9862,7 +11577,24 @@
                 <a:ea typeface="Helvetica Neue" pitchFamily="34" charset="-122"/>
                 <a:cs typeface="Helvetica Neue" pitchFamily="34" charset="-120"/>
               </a:rPr>
-              <a:t>Zero lock-in.</a:t>
+              <a:t>competing for lines</a:t>
+            </a:r>
+            <a:pPr algn="l" indent="0" marL="0">
+              <a:lnSpc>
+                <a:spcPct val="102000"/>
+              </a:lnSpc>
+              <a:buNone/>
+            </a:pPr>
+            <a:r>
+              <a:rPr lang="en-US" sz="3300" b="1" dirty="0">
+                <a:solidFill>
+                  <a:srgbClr val="0F1B2E"/>
+                </a:solidFill>
+                <a:latin typeface="Helvetica Neue" pitchFamily="34" charset="0"/>
+                <a:ea typeface="Helvetica Neue" pitchFamily="34" charset="-122"/>
+                <a:cs typeface="Helvetica Neue" pitchFamily="34" charset="-120"/>
+              </a:rPr>
+              <a:t>.</a:t>
             </a:r>
             <a:endParaRPr lang="en-US" sz="3300" dirty="0"/>
           </a:p>
@@ -9877,182 +11609,11 @@
         <p:spPr>
           <a:xfrm>
             <a:off x="566928" y="2560320"/>
-            <a:ext cx="3442106" cy="2834640"/>
+            <a:ext cx="5300320" cy="2743200"/>
           </a:xfrm>
           <a:prstGeom prst="roundRect">
             <a:avLst>
-              <a:gd name="adj" fmla="val 2903"/>
-            </a:avLst>
-          </a:prstGeom>
-          <a:solidFill>
-            <a:srgbClr val="0A1526"/>
-          </a:solidFill>
-          <a:ln/>
-          <a:effectLst>
-            <a:outerShdw sx="100000" sy="100000" kx="0" ky="0" algn="bl" rotWithShape="0" blurRad="88900" dist="38100" dir="8100000">
-              <a:srgbClr val="0A1526">
-                <a:alpha val="10000"/>
-              </a:srgbClr>
-            </a:outerShdw>
-          </a:effectLst>
-        </p:spPr>
-      </p:sp>
-      <p:sp>
-        <p:nvSpPr>
-          <p:cNvPr id="7" name="Shape 5"/>
-          <p:cNvSpPr/>
-          <p:nvPr/>
-        </p:nvSpPr>
-        <p:spPr>
-          <a:xfrm>
-            <a:off x="859536" y="2871216"/>
-            <a:ext cx="1371600" cy="365760"/>
-          </a:xfrm>
-          <a:prstGeom prst="roundRect">
-            <a:avLst>
-              <a:gd name="adj" fmla="val 50000"/>
-            </a:avLst>
-          </a:prstGeom>
-          <a:solidFill>
-            <a:srgbClr val="15B3A4"/>
-          </a:solidFill>
-          <a:ln/>
-        </p:spPr>
-      </p:sp>
-      <p:sp>
-        <p:nvSpPr>
-          <p:cNvPr id="8" name="Text 6"/>
-          <p:cNvSpPr/>
-          <p:nvPr/>
-        </p:nvSpPr>
-        <p:spPr>
-          <a:xfrm>
-            <a:off x="859536" y="2871216"/>
-            <a:ext cx="1371600" cy="365760"/>
-          </a:xfrm>
-          <a:prstGeom prst="rect">
-            <a:avLst/>
-          </a:prstGeom>
-          <a:noFill/>
-          <a:ln/>
-        </p:spPr>
-        <p:txBody>
-          <a:bodyPr wrap="square" lIns="0" tIns="0" rIns="0" bIns="0" rtlCol="0" anchor="ctr"/>
-          <a:lstStyle/>
-          <a:p>
-            <a:pPr algn="ctr" indent="0" marL="0">
-              <a:buNone/>
-            </a:pPr>
-            <a:r>
-              <a:rPr lang="en-US" sz="950" b="1" spc="100" kern="0" dirty="0">
-                <a:solidFill>
-                  <a:srgbClr val="04211D"/>
-                </a:solidFill>
-                <a:latin typeface="Helvetica Neue" pitchFamily="34" charset="0"/>
-                <a:ea typeface="Helvetica Neue" pitchFamily="34" charset="-122"/>
-                <a:cs typeface="Helvetica Neue" pitchFamily="34" charset="-120"/>
-              </a:rPr>
-              <a:t>RECOMMENDED</a:t>
-            </a:r>
-            <a:endParaRPr lang="en-US" sz="950" dirty="0"/>
-          </a:p>
-        </p:txBody>
-      </p:sp>
-      <p:sp>
-        <p:nvSpPr>
-          <p:cNvPr id="9" name="Text 7"/>
-          <p:cNvSpPr/>
-          <p:nvPr/>
-        </p:nvSpPr>
-        <p:spPr>
-          <a:xfrm>
-            <a:off x="859536" y="3429000"/>
-            <a:ext cx="2856890" cy="548640"/>
-          </a:xfrm>
-          <a:prstGeom prst="rect">
-            <a:avLst/>
-          </a:prstGeom>
-          <a:noFill/>
-          <a:ln/>
-        </p:spPr>
-        <p:txBody>
-          <a:bodyPr wrap="square" lIns="0" tIns="0" rIns="0" bIns="0" rtlCol="0" anchor="ctr"/>
-          <a:lstStyle/>
-          <a:p>
-            <a:pPr indent="0" marL="0">
-              <a:buNone/>
-            </a:pPr>
-            <a:r>
-              <a:rPr lang="en-US" sz="1900" b="1" dirty="0">
-                <a:solidFill>
-                  <a:srgbClr val="FFFFFF"/>
-                </a:solidFill>
-                <a:latin typeface="Helvetica Neue" pitchFamily="34" charset="0"/>
-                <a:ea typeface="Helvetica Neue" pitchFamily="34" charset="-122"/>
-                <a:cs typeface="Helvetica Neue" pitchFamily="34" charset="-120"/>
-              </a:rPr>
-              <a:t>Run local</a:t>
-            </a:r>
-            <a:endParaRPr lang="en-US" sz="1900" dirty="0"/>
-          </a:p>
-        </p:txBody>
-      </p:sp>
-      <p:sp>
-        <p:nvSpPr>
-          <p:cNvPr id="10" name="Text 8"/>
-          <p:cNvSpPr/>
-          <p:nvPr/>
-        </p:nvSpPr>
-        <p:spPr>
-          <a:xfrm>
-            <a:off x="859536" y="4023360"/>
-            <a:ext cx="2856890" cy="1188720"/>
-          </a:xfrm>
-          <a:prstGeom prst="rect">
-            <a:avLst/>
-          </a:prstGeom>
-          <a:noFill/>
-          <a:ln/>
-        </p:spPr>
-        <p:txBody>
-          <a:bodyPr wrap="square" lIns="0" tIns="0" rIns="0" bIns="0" rtlCol="0" anchor="ctr"/>
-          <a:lstStyle/>
-          <a:p>
-            <a:pPr indent="0" marL="0">
-              <a:lnSpc>
-                <a:spcPct val="130000"/>
-              </a:lnSpc>
-              <a:buNone/>
-            </a:pPr>
-            <a:r>
-              <a:rPr lang="en-US" sz="1300" dirty="0">
-                <a:solidFill>
-                  <a:srgbClr val="9FB0C8"/>
-                </a:solidFill>
-                <a:latin typeface="Helvetica Neue" pitchFamily="34" charset="0"/>
-                <a:ea typeface="Helvetica Neue" pitchFamily="34" charset="-122"/>
-                <a:cs typeface="Helvetica Neue" pitchFamily="34" charset="-120"/>
-              </a:rPr>
-              <a:t>Download &amp; run the IDE on your machine — local read/write + AI, the smoothest path.</a:t>
-            </a:r>
-            <a:endParaRPr lang="en-US" sz="1300" dirty="0"/>
-          </a:p>
-        </p:txBody>
-      </p:sp>
-      <p:sp>
-        <p:nvSpPr>
-          <p:cNvPr id="11" name="Shape 9"/>
-          <p:cNvSpPr/>
-          <p:nvPr/>
-        </p:nvSpPr>
-        <p:spPr>
-          <a:xfrm>
-            <a:off x="4374794" y="2560320"/>
-            <a:ext cx="3442106" cy="2834640"/>
-          </a:xfrm>
-          <a:prstGeom prst="roundRect">
-            <a:avLst>
-              <a:gd name="adj" fmla="val 2903"/>
+              <a:gd name="adj" fmla="val 3000"/>
             </a:avLst>
           </a:prstGeom>
           <a:solidFill>
@@ -10075,75 +11636,34 @@
       </p:sp>
       <p:sp>
         <p:nvSpPr>
-          <p:cNvPr id="12" name="Shape 10"/>
-          <p:cNvSpPr/>
-          <p:nvPr/>
-        </p:nvSpPr>
-        <p:spPr>
-          <a:xfrm>
-            <a:off x="4667402" y="2871216"/>
-            <a:ext cx="1371600" cy="365760"/>
-          </a:xfrm>
-          <a:prstGeom prst="roundRect">
-            <a:avLst>
-              <a:gd name="adj" fmla="val 50000"/>
-            </a:avLst>
+          <p:cNvPr id="7" name="Shape 5"/>
+          <p:cNvSpPr/>
+          <p:nvPr/>
+        </p:nvSpPr>
+        <p:spPr>
+          <a:xfrm>
+            <a:off x="886968" y="2880360"/>
+            <a:ext cx="457200" cy="73152"/>
+          </a:xfrm>
+          <a:prstGeom prst="rect">
+            <a:avLst/>
           </a:prstGeom>
           <a:solidFill>
-            <a:srgbClr val="EAF2F8"/>
+            <a:srgbClr val="15B3A4"/>
           </a:solidFill>
           <a:ln/>
         </p:spPr>
       </p:sp>
       <p:sp>
         <p:nvSpPr>
-          <p:cNvPr id="13" name="Text 11"/>
-          <p:cNvSpPr/>
-          <p:nvPr/>
-        </p:nvSpPr>
-        <p:spPr>
-          <a:xfrm>
-            <a:off x="4667402" y="2871216"/>
-            <a:ext cx="1371600" cy="365760"/>
-          </a:xfrm>
-          <a:prstGeom prst="rect">
-            <a:avLst/>
-          </a:prstGeom>
-          <a:noFill/>
-          <a:ln/>
-        </p:spPr>
-        <p:txBody>
-          <a:bodyPr wrap="square" lIns="0" tIns="0" rIns="0" bIns="0" rtlCol="0" anchor="ctr"/>
-          <a:lstStyle/>
-          <a:p>
-            <a:pPr algn="ctr" indent="0" marL="0">
-              <a:buNone/>
-            </a:pPr>
-            <a:r>
-              <a:rPr lang="en-US" sz="950" b="1" spc="100" kern="0" dirty="0">
-                <a:solidFill>
-                  <a:srgbClr val="1F4FA8"/>
-                </a:solidFill>
-                <a:latin typeface="Helvetica Neue" pitchFamily="34" charset="0"/>
-                <a:ea typeface="Helvetica Neue" pitchFamily="34" charset="-122"/>
-                <a:cs typeface="Helvetica Neue" pitchFamily="34" charset="-120"/>
-              </a:rPr>
-              <a:t>OPTIONAL</a:t>
-            </a:r>
-            <a:endParaRPr lang="en-US" sz="950" dirty="0"/>
-          </a:p>
-        </p:txBody>
-      </p:sp>
-      <p:sp>
-        <p:nvSpPr>
-          <p:cNvPr id="14" name="Text 12"/>
-          <p:cNvSpPr/>
-          <p:nvPr/>
-        </p:nvSpPr>
-        <p:spPr>
-          <a:xfrm>
-            <a:off x="4667402" y="3429000"/>
-            <a:ext cx="2856890" cy="548640"/>
+          <p:cNvPr id="8" name="Text 6"/>
+          <p:cNvSpPr/>
+          <p:nvPr/>
+        </p:nvSpPr>
+        <p:spPr>
+          <a:xfrm>
+            <a:off x="886968" y="3017520"/>
+            <a:ext cx="4660240" cy="502920"/>
           </a:xfrm>
           <a:prstGeom prst="rect">
             <a:avLst/>
@@ -10159,7 +11679,7 @@
               <a:buNone/>
             </a:pPr>
             <a:r>
-              <a:rPr lang="en-US" sz="1900" b="1" dirty="0">
+              <a:rPr lang="en-US" sz="1700" b="1" dirty="0">
                 <a:solidFill>
                   <a:srgbClr val="0F1B2E"/>
                 </a:solidFill>
@@ -10167,22 +11687,22 @@
                 <a:ea typeface="Helvetica Neue" pitchFamily="34" charset="-122"/>
                 <a:cs typeface="Helvetica Neue" pitchFamily="34" charset="-120"/>
               </a:rPr>
-              <a:t>Deploy to cloud</a:t>
-            </a:r>
-            <a:endParaRPr lang="en-US" sz="1900" dirty="0"/>
-          </a:p>
-        </p:txBody>
-      </p:sp>
-      <p:sp>
-        <p:nvSpPr>
-          <p:cNvPr id="15" name="Text 13"/>
-          <p:cNvSpPr/>
-          <p:nvPr/>
-        </p:nvSpPr>
-        <p:spPr>
-          <a:xfrm>
-            <a:off x="4667402" y="4023360"/>
-            <a:ext cx="2856890" cy="1188720"/>
+              <a:t>Human + AI, at the component layer</a:t>
+            </a:r>
+            <a:endParaRPr lang="en-US" sz="1700" dirty="0"/>
+          </a:p>
+        </p:txBody>
+      </p:sp>
+      <p:sp>
+        <p:nvSpPr>
+          <p:cNvPr id="9" name="Text 7"/>
+          <p:cNvSpPr/>
+          <p:nvPr/>
+        </p:nvSpPr>
+        <p:spPr>
+          <a:xfrm>
+            <a:off x="886968" y="3611880"/>
+            <a:ext cx="4660240" cy="1463040"/>
           </a:xfrm>
           <a:prstGeom prst="rect">
             <a:avLst/>
@@ -10201,7 +11721,7 @@
               <a:buNone/>
             </a:pPr>
             <a:r>
-              <a:rPr lang="en-US" sz="1300" dirty="0">
+              <a:rPr lang="en-US" sz="1350" dirty="0">
                 <a:solidFill>
                   <a:srgbClr val="2A3A51"/>
                 </a:solidFill>
@@ -10209,37 +11729,32 @@
                 <a:ea typeface="Helvetica Neue" pitchFamily="34" charset="-122"/>
                 <a:cs typeface="Helvetica Neue" pitchFamily="34" charset="-120"/>
               </a:rPr>
-              <a:t>One click to managed cloud. Pay-as-you-go compute. Zero server ops.</a:t>
-            </a:r>
-            <a:endParaRPr lang="en-US" sz="1300" dirty="0"/>
-          </a:p>
-        </p:txBody>
-      </p:sp>
-      <p:sp>
-        <p:nvSpPr>
-          <p:cNvPr id="16" name="Shape 14"/>
-          <p:cNvSpPr/>
-          <p:nvPr/>
-        </p:nvSpPr>
-        <p:spPr>
-          <a:xfrm>
-            <a:off x="8182661" y="2560320"/>
-            <a:ext cx="3442106" cy="2834640"/>
+              <a:t>Components are self-contained units. People and agents both work on structure and merge at the component layer — no fighting over the same lines, no git text-conflicts.</a:t>
+            </a:r>
+            <a:endParaRPr lang="en-US" sz="1350" dirty="0"/>
+          </a:p>
+        </p:txBody>
+      </p:sp>
+      <p:sp>
+        <p:nvSpPr>
+          <p:cNvPr id="10" name="Shape 8"/>
+          <p:cNvSpPr/>
+          <p:nvPr/>
+        </p:nvSpPr>
+        <p:spPr>
+          <a:xfrm>
+            <a:off x="6324448" y="2560320"/>
+            <a:ext cx="5300320" cy="2743200"/>
           </a:xfrm>
           <a:prstGeom prst="roundRect">
             <a:avLst>
-              <a:gd name="adj" fmla="val 2903"/>
+              <a:gd name="adj" fmla="val 3000"/>
             </a:avLst>
           </a:prstGeom>
           <a:solidFill>
-            <a:srgbClr val="FFFFFF"/>
+            <a:srgbClr val="0A1526"/>
           </a:solidFill>
-          <a:ln w="12700">
-            <a:solidFill>
-              <a:srgbClr val="E4EAF1"/>
-            </a:solidFill>
-            <a:prstDash val="solid"/>
-          </a:ln>
+          <a:ln/>
           <a:effectLst>
             <a:outerShdw sx="100000" sy="100000" kx="0" ky="0" algn="bl" rotWithShape="0" blurRad="88900" dist="38100" dir="8100000">
               <a:srgbClr val="0A1526">
@@ -10251,75 +11766,34 @@
       </p:sp>
       <p:sp>
         <p:nvSpPr>
-          <p:cNvPr id="17" name="Shape 15"/>
-          <p:cNvSpPr/>
-          <p:nvPr/>
-        </p:nvSpPr>
-        <p:spPr>
-          <a:xfrm>
-            <a:off x="8475269" y="2871216"/>
-            <a:ext cx="1371600" cy="365760"/>
-          </a:xfrm>
-          <a:prstGeom prst="roundRect">
-            <a:avLst>
-              <a:gd name="adj" fmla="val 50000"/>
-            </a:avLst>
+          <p:cNvPr id="11" name="Shape 9"/>
+          <p:cNvSpPr/>
+          <p:nvPr/>
+        </p:nvSpPr>
+        <p:spPr>
+          <a:xfrm>
+            <a:off x="6644488" y="2880360"/>
+            <a:ext cx="457200" cy="73152"/>
+          </a:xfrm>
+          <a:prstGeom prst="rect">
+            <a:avLst/>
           </a:prstGeom>
           <a:solidFill>
-            <a:srgbClr val="EAF2F8"/>
+            <a:srgbClr val="7FE7DA"/>
           </a:solidFill>
           <a:ln/>
         </p:spPr>
       </p:sp>
       <p:sp>
         <p:nvSpPr>
-          <p:cNvPr id="18" name="Text 16"/>
-          <p:cNvSpPr/>
-          <p:nvPr/>
-        </p:nvSpPr>
-        <p:spPr>
-          <a:xfrm>
-            <a:off x="8475269" y="2871216"/>
-            <a:ext cx="1371600" cy="365760"/>
-          </a:xfrm>
-          <a:prstGeom prst="rect">
-            <a:avLst/>
-          </a:prstGeom>
-          <a:noFill/>
-          <a:ln/>
-        </p:spPr>
-        <p:txBody>
-          <a:bodyPr wrap="square" lIns="0" tIns="0" rIns="0" bIns="0" rtlCol="0" anchor="ctr"/>
-          <a:lstStyle/>
-          <a:p>
-            <a:pPr algn="ctr" indent="0" marL="0">
-              <a:buNone/>
-            </a:pPr>
-            <a:r>
-              <a:rPr lang="en-US" sz="950" b="1" spc="100" kern="0" dirty="0">
-                <a:solidFill>
-                  <a:srgbClr val="1F4FA8"/>
-                </a:solidFill>
-                <a:latin typeface="Helvetica Neue" pitchFamily="34" charset="0"/>
-                <a:ea typeface="Helvetica Neue" pitchFamily="34" charset="-122"/>
-                <a:cs typeface="Helvetica Neue" pitchFamily="34" charset="-120"/>
-              </a:rPr>
-              <a:t>0 BINDING</a:t>
-            </a:r>
-            <a:endParaRPr lang="en-US" sz="950" dirty="0"/>
-          </a:p>
-        </p:txBody>
-      </p:sp>
-      <p:sp>
-        <p:nvSpPr>
-          <p:cNvPr id="19" name="Text 17"/>
-          <p:cNvSpPr/>
-          <p:nvPr/>
-        </p:nvSpPr>
-        <p:spPr>
-          <a:xfrm>
-            <a:off x="8475269" y="3429000"/>
-            <a:ext cx="2856890" cy="548640"/>
+          <p:cNvPr id="12" name="Text 10"/>
+          <p:cNvSpPr/>
+          <p:nvPr/>
+        </p:nvSpPr>
+        <p:spPr>
+          <a:xfrm>
+            <a:off x="6644488" y="3017520"/>
+            <a:ext cx="4660240" cy="502920"/>
           </a:xfrm>
           <a:prstGeom prst="rect">
             <a:avLst/>
@@ -10335,30 +11809,30 @@
               <a:buNone/>
             </a:pPr>
             <a:r>
-              <a:rPr lang="en-US" sz="1900" b="1" dirty="0">
-                <a:solidFill>
-                  <a:srgbClr val="0F1B2E"/>
-                </a:solidFill>
-                <a:latin typeface="Helvetica Neue" pitchFamily="34" charset="0"/>
-                <a:ea typeface="Helvetica Neue" pitchFamily="34" charset="-122"/>
-                <a:cs typeface="Helvetica Neue" pitchFamily="34" charset="-120"/>
-              </a:rPr>
-              <a:t>Export source</a:t>
-            </a:r>
-            <a:endParaRPr lang="en-US" sz="1900" dirty="0"/>
-          </a:p>
-        </p:txBody>
-      </p:sp>
-      <p:sp>
-        <p:nvSpPr>
-          <p:cNvPr id="20" name="Text 18"/>
-          <p:cNvSpPr/>
-          <p:nvPr/>
-        </p:nvSpPr>
-        <p:spPr>
-          <a:xfrm>
-            <a:off x="8475269" y="4023360"/>
-            <a:ext cx="2856890" cy="1188720"/>
+              <a:rPr lang="en-US" sz="1700" b="1" dirty="0">
+                <a:solidFill>
+                  <a:srgbClr val="FFFFFF"/>
+                </a:solidFill>
+                <a:latin typeface="Helvetica Neue" pitchFamily="34" charset="0"/>
+                <a:ea typeface="Helvetica Neue" pitchFamily="34" charset="-122"/>
+                <a:cs typeface="Helvetica Neue" pitchFamily="34" charset="-120"/>
+              </a:rPr>
+              <a:t>The right model for every node</a:t>
+            </a:r>
+            <a:endParaRPr lang="en-US" sz="1700" dirty="0"/>
+          </a:p>
+        </p:txBody>
+      </p:sp>
+      <p:sp>
+        <p:nvSpPr>
+          <p:cNvPr id="13" name="Text 11"/>
+          <p:cNvSpPr/>
+          <p:nvPr/>
+        </p:nvSpPr>
+        <p:spPr>
+          <a:xfrm>
+            <a:off x="6644488" y="3611880"/>
+            <a:ext cx="4660240" cy="1463040"/>
           </a:xfrm>
           <a:prstGeom prst="rect">
             <a:avLst/>
@@ -10377,54 +11851,15 @@
               <a:buNone/>
             </a:pPr>
             <a:r>
-              <a:rPr lang="en-US" sz="1300" dirty="0">
-                <a:solidFill>
-                  <a:srgbClr val="2A3A51"/>
-                </a:solidFill>
-                <a:latin typeface="Helvetica Neue" pitchFamily="34" charset="0"/>
-                <a:ea typeface="Helvetica Neue" pitchFamily="34" charset="-122"/>
-                <a:cs typeface="Helvetica Neue" pitchFamily="34" charset="-120"/>
-              </a:rPr>
-              <a:t>Take the React + Node source out and self-host anywhere. Full data sovereignty.</a:t>
-            </a:r>
-            <a:endParaRPr lang="en-US" sz="1300" dirty="0"/>
-          </a:p>
-        </p:txBody>
-      </p:sp>
-      <p:sp>
-        <p:nvSpPr>
-          <p:cNvPr id="21" name="Text 19"/>
-          <p:cNvSpPr/>
-          <p:nvPr/>
-        </p:nvSpPr>
-        <p:spPr>
-          <a:xfrm>
-            <a:off x="566928" y="5623560"/>
-            <a:ext cx="11057839" cy="411480"/>
-          </a:xfrm>
-          <a:prstGeom prst="rect">
-            <a:avLst/>
-          </a:prstGeom>
-          <a:noFill/>
-          <a:ln/>
-        </p:spPr>
-        <p:txBody>
-          <a:bodyPr wrap="square" lIns="0" tIns="0" rIns="0" bIns="0" rtlCol="0" anchor="ctr"/>
-          <a:lstStyle/>
-          <a:p>
-            <a:pPr algn="ctr" indent="0" marL="0">
-              <a:buNone/>
-            </a:pPr>
-            <a:r>
-              <a:rPr lang="en-US" sz="1350" i="1" dirty="0">
-                <a:solidFill>
-                  <a:srgbClr val="0E9F91"/>
-                </a:solidFill>
-                <a:latin typeface="Helvetica Neue" pitchFamily="34" charset="0"/>
-                <a:ea typeface="Helvetica Neue" pitchFamily="34" charset="-122"/>
-                <a:cs typeface="Helvetica Neue" pitchFamily="34" charset="-120"/>
-              </a:rPr>
-              <a:t>Use the cloud when it helps — walk away with your code whenever you want.</a:t>
+              <a:rPr lang="en-US" sz="1350" dirty="0">
+                <a:solidFill>
+                  <a:srgbClr val="9FB0C8"/>
+                </a:solidFill>
+                <a:latin typeface="Helvetica Neue" pitchFamily="34" charset="0"/>
+                <a:ea typeface="Helvetica Neue" pitchFamily="34" charset="-122"/>
+                <a:cs typeface="Helvetica Neue" pitchFamily="34" charset="-120"/>
+              </a:rPr>
+              <a:t>Route expensive models to the hard nodes and cheap models or tools to the routine ones. Capability where it counts, savings everywhere else.</a:t>
             </a:r>
             <a:endParaRPr lang="en-US" sz="1350" dirty="0"/>
           </a:p>
@@ -10432,7 +11867,7 @@
       </p:sp>
       <p:sp>
         <p:nvSpPr>
-          <p:cNvPr id="22" name="Shape 20"/>
+          <p:cNvPr id="14" name="Shape 12"/>
           <p:cNvSpPr/>
           <p:nvPr/>
         </p:nvSpPr>
@@ -10455,7 +11890,7 @@
       </p:sp>
       <p:sp>
         <p:nvSpPr>
-          <p:cNvPr id="23" name="Text 21"/>
+          <p:cNvPr id="15" name="Text 13"/>
           <p:cNvSpPr/>
           <p:nvPr/>
         </p:nvSpPr>
@@ -10508,7 +11943,7 @@
       </p:sp>
       <p:sp>
         <p:nvSpPr>
-          <p:cNvPr id="24" name="Text 22"/>
+          <p:cNvPr id="16" name="Text 14"/>
           <p:cNvSpPr/>
           <p:nvPr/>
         </p:nvSpPr>
@@ -10559,7 +11994,7 @@
     <p:bg>
       <p:bgPr>
         <a:solidFill>
-          <a:srgbClr val="0A1526"/>
+          <a:srgbClr val="F5F9FC"/>
         </a:solidFill>
       </p:bgPr>
     </p:bg>
@@ -10585,11 +12020,13 @@
         </p:nvSpPr>
         <p:spPr>
           <a:xfrm>
-            <a:off x="0" y="6711696"/>
-            <a:ext cx="12191695" cy="146304"/>
-          </a:xfrm>
-          <a:prstGeom prst="rect">
-            <a:avLst/>
+            <a:off x="566928" y="566928"/>
+            <a:ext cx="384048" cy="384048"/>
+          </a:xfrm>
+          <a:prstGeom prst="roundRect">
+            <a:avLst>
+              <a:gd name="adj" fmla="val 16667"/>
+            </a:avLst>
           </a:prstGeom>
           <a:solidFill>
             <a:srgbClr val="15B3A4"/>
@@ -10599,60 +12036,417 @@
       </p:sp>
       <p:sp>
         <p:nvSpPr>
-          <p:cNvPr id="3" name="Shape 1"/>
-          <p:cNvSpPr/>
-          <p:nvPr/>
-        </p:nvSpPr>
-        <p:spPr>
-          <a:xfrm>
-            <a:off x="566928" y="640080"/>
-            <a:ext cx="1396099" cy="603504"/>
+          <p:cNvPr id="3" name="Text 1"/>
+          <p:cNvSpPr/>
+          <p:nvPr/>
+        </p:nvSpPr>
+        <p:spPr>
+          <a:xfrm>
+            <a:off x="566928" y="566928"/>
+            <a:ext cx="384048" cy="384048"/>
+          </a:xfrm>
+          <a:prstGeom prst="rect">
+            <a:avLst/>
+          </a:prstGeom>
+          <a:noFill/>
+          <a:ln/>
+        </p:spPr>
+        <p:txBody>
+          <a:bodyPr wrap="square" lIns="0" tIns="0" rIns="0" bIns="0" rtlCol="0" anchor="ctr"/>
+          <a:lstStyle/>
+          <a:p>
+            <a:pPr algn="ctr" indent="0" marL="0">
+              <a:buNone/>
+            </a:pPr>
+            <a:r>
+              <a:rPr lang="en-US" sz="1300" b="1" dirty="0">
+                <a:solidFill>
+                  <a:srgbClr val="FFFFFF"/>
+                </a:solidFill>
+                <a:latin typeface="Helvetica Neue" pitchFamily="34" charset="0"/>
+                <a:ea typeface="Helvetica Neue" pitchFamily="34" charset="-122"/>
+                <a:cs typeface="Helvetica Neue" pitchFamily="34" charset="-120"/>
+              </a:rPr>
+              <a:t>17</a:t>
+            </a:r>
+            <a:endParaRPr lang="en-US" sz="1300" dirty="0"/>
+          </a:p>
+        </p:txBody>
+      </p:sp>
+      <p:sp>
+        <p:nvSpPr>
+          <p:cNvPr id="4" name="Text 2"/>
+          <p:cNvSpPr/>
+          <p:nvPr/>
+        </p:nvSpPr>
+        <p:spPr>
+          <a:xfrm>
+            <a:off x="1078992" y="566928"/>
+            <a:ext cx="10545775" cy="384048"/>
+          </a:xfrm>
+          <a:prstGeom prst="rect">
+            <a:avLst/>
+          </a:prstGeom>
+          <a:noFill/>
+          <a:ln/>
+        </p:spPr>
+        <p:txBody>
+          <a:bodyPr wrap="square" lIns="0" tIns="0" rIns="0" bIns="0" rtlCol="0" anchor="ctr"/>
+          <a:lstStyle/>
+          <a:p>
+            <a:pPr algn="l" indent="0" marL="0">
+              <a:buNone/>
+            </a:pPr>
+            <a:r>
+              <a:rPr lang="en-US" sz="1150" b="1" spc="300" kern="0" dirty="0">
+                <a:solidFill>
+                  <a:srgbClr val="0E9F91"/>
+                </a:solidFill>
+                <a:latin typeface="Helvetica Neue" pitchFamily="34" charset="0"/>
+                <a:ea typeface="Helvetica Neue" pitchFamily="34" charset="-122"/>
+                <a:cs typeface="Helvetica Neue" pitchFamily="34" charset="-120"/>
+              </a:rPr>
+              <a:t>YOUR WAY</a:t>
+            </a:r>
+            <a:endParaRPr lang="en-US" sz="1150" dirty="0"/>
+          </a:p>
+        </p:txBody>
+      </p:sp>
+      <p:sp>
+        <p:nvSpPr>
+          <p:cNvPr id="5" name="Text 3"/>
+          <p:cNvSpPr/>
+          <p:nvPr/>
+        </p:nvSpPr>
+        <p:spPr>
+          <a:xfrm>
+            <a:off x="566928" y="1097280"/>
+            <a:ext cx="11057839" cy="1051560"/>
+          </a:xfrm>
+          <a:prstGeom prst="rect">
+            <a:avLst/>
+          </a:prstGeom>
+          <a:noFill/>
+          <a:ln/>
+        </p:spPr>
+        <p:txBody>
+          <a:bodyPr wrap="square" lIns="0" tIns="0" rIns="0" bIns="0" rtlCol="0" anchor="t"/>
+          <a:lstStyle/>
+          <a:p>
+            <a:pPr algn="l" indent="0" marL="0">
+              <a:lnSpc>
+                <a:spcPct val="102000"/>
+              </a:lnSpc>
+              <a:buNone/>
+            </a:pPr>
+            <a:r>
+              <a:rPr lang="en-US" sz="3300" b="1" dirty="0">
+                <a:solidFill>
+                  <a:srgbClr val="0F1B2E"/>
+                </a:solidFill>
+                <a:latin typeface="Helvetica Neue" pitchFamily="34" charset="0"/>
+                <a:ea typeface="Helvetica Neue" pitchFamily="34" charset="-122"/>
+                <a:cs typeface="Helvetica Neue" pitchFamily="34" charset="-120"/>
+              </a:rPr>
+              <a:t>Local-first. Cloud optional. </a:t>
+            </a:r>
+            <a:pPr algn="l" indent="0" marL="0">
+              <a:lnSpc>
+                <a:spcPct val="102000"/>
+              </a:lnSpc>
+              <a:buNone/>
+            </a:pPr>
+            <a:r>
+              <a:rPr lang="en-US" sz="3300" b="1" dirty="0">
+                <a:solidFill>
+                  <a:srgbClr val="0E9F91"/>
+                </a:solidFill>
+                <a:latin typeface="Helvetica Neue" pitchFamily="34" charset="0"/>
+                <a:ea typeface="Helvetica Neue" pitchFamily="34" charset="-122"/>
+                <a:cs typeface="Helvetica Neue" pitchFamily="34" charset="-120"/>
+              </a:rPr>
+              <a:t>Zero lock-in.</a:t>
+            </a:r>
+            <a:endParaRPr lang="en-US" sz="3300" dirty="0"/>
+          </a:p>
+        </p:txBody>
+      </p:sp>
+      <p:sp>
+        <p:nvSpPr>
+          <p:cNvPr id="6" name="Shape 4"/>
+          <p:cNvSpPr/>
+          <p:nvPr/>
+        </p:nvSpPr>
+        <p:spPr>
+          <a:xfrm>
+            <a:off x="566928" y="2560320"/>
+            <a:ext cx="3442106" cy="2834640"/>
           </a:xfrm>
           <a:prstGeom prst="roundRect">
             <a:avLst>
-              <a:gd name="adj" fmla="val 12121"/>
+              <a:gd name="adj" fmla="val 2903"/>
+            </a:avLst>
+          </a:prstGeom>
+          <a:solidFill>
+            <a:srgbClr val="0A1526"/>
+          </a:solidFill>
+          <a:ln/>
+          <a:effectLst>
+            <a:outerShdw sx="100000" sy="100000" kx="0" ky="0" algn="bl" rotWithShape="0" blurRad="88900" dist="38100" dir="8100000">
+              <a:srgbClr val="0A1526">
+                <a:alpha val="10000"/>
+              </a:srgbClr>
+            </a:outerShdw>
+          </a:effectLst>
+        </p:spPr>
+      </p:sp>
+      <p:sp>
+        <p:nvSpPr>
+          <p:cNvPr id="7" name="Shape 5"/>
+          <p:cNvSpPr/>
+          <p:nvPr/>
+        </p:nvSpPr>
+        <p:spPr>
+          <a:xfrm>
+            <a:off x="859536" y="2871216"/>
+            <a:ext cx="1371600" cy="365760"/>
+          </a:xfrm>
+          <a:prstGeom prst="roundRect">
+            <a:avLst>
+              <a:gd name="adj" fmla="val 50000"/>
+            </a:avLst>
+          </a:prstGeom>
+          <a:solidFill>
+            <a:srgbClr val="15B3A4"/>
+          </a:solidFill>
+          <a:ln/>
+        </p:spPr>
+      </p:sp>
+      <p:sp>
+        <p:nvSpPr>
+          <p:cNvPr id="8" name="Text 6"/>
+          <p:cNvSpPr/>
+          <p:nvPr/>
+        </p:nvSpPr>
+        <p:spPr>
+          <a:xfrm>
+            <a:off x="859536" y="2871216"/>
+            <a:ext cx="1371600" cy="365760"/>
+          </a:xfrm>
+          <a:prstGeom prst="rect">
+            <a:avLst/>
+          </a:prstGeom>
+          <a:noFill/>
+          <a:ln/>
+        </p:spPr>
+        <p:txBody>
+          <a:bodyPr wrap="square" lIns="0" tIns="0" rIns="0" bIns="0" rtlCol="0" anchor="ctr"/>
+          <a:lstStyle/>
+          <a:p>
+            <a:pPr algn="ctr" indent="0" marL="0">
+              <a:buNone/>
+            </a:pPr>
+            <a:r>
+              <a:rPr lang="en-US" sz="950" b="1" spc="100" kern="0" dirty="0">
+                <a:solidFill>
+                  <a:srgbClr val="04211D"/>
+                </a:solidFill>
+                <a:latin typeface="Helvetica Neue" pitchFamily="34" charset="0"/>
+                <a:ea typeface="Helvetica Neue" pitchFamily="34" charset="-122"/>
+                <a:cs typeface="Helvetica Neue" pitchFamily="34" charset="-120"/>
+              </a:rPr>
+              <a:t>RECOMMENDED</a:t>
+            </a:r>
+            <a:endParaRPr lang="en-US" sz="950" dirty="0"/>
+          </a:p>
+        </p:txBody>
+      </p:sp>
+      <p:sp>
+        <p:nvSpPr>
+          <p:cNvPr id="9" name="Text 7"/>
+          <p:cNvSpPr/>
+          <p:nvPr/>
+        </p:nvSpPr>
+        <p:spPr>
+          <a:xfrm>
+            <a:off x="859536" y="3429000"/>
+            <a:ext cx="2856890" cy="548640"/>
+          </a:xfrm>
+          <a:prstGeom prst="rect">
+            <a:avLst/>
+          </a:prstGeom>
+          <a:noFill/>
+          <a:ln/>
+        </p:spPr>
+        <p:txBody>
+          <a:bodyPr wrap="square" lIns="0" tIns="0" rIns="0" bIns="0" rtlCol="0" anchor="ctr"/>
+          <a:lstStyle/>
+          <a:p>
+            <a:pPr indent="0" marL="0">
+              <a:buNone/>
+            </a:pPr>
+            <a:r>
+              <a:rPr lang="en-US" sz="1900" b="1" dirty="0">
+                <a:solidFill>
+                  <a:srgbClr val="FFFFFF"/>
+                </a:solidFill>
+                <a:latin typeface="Helvetica Neue" pitchFamily="34" charset="0"/>
+                <a:ea typeface="Helvetica Neue" pitchFamily="34" charset="-122"/>
+                <a:cs typeface="Helvetica Neue" pitchFamily="34" charset="-120"/>
+              </a:rPr>
+              <a:t>Run local</a:t>
+            </a:r>
+            <a:endParaRPr lang="en-US" sz="1900" dirty="0"/>
+          </a:p>
+        </p:txBody>
+      </p:sp>
+      <p:sp>
+        <p:nvSpPr>
+          <p:cNvPr id="10" name="Text 8"/>
+          <p:cNvSpPr/>
+          <p:nvPr/>
+        </p:nvSpPr>
+        <p:spPr>
+          <a:xfrm>
+            <a:off x="859536" y="4023360"/>
+            <a:ext cx="2856890" cy="1188720"/>
+          </a:xfrm>
+          <a:prstGeom prst="rect">
+            <a:avLst/>
+          </a:prstGeom>
+          <a:noFill/>
+          <a:ln/>
+        </p:spPr>
+        <p:txBody>
+          <a:bodyPr wrap="square" lIns="0" tIns="0" rIns="0" bIns="0" rtlCol="0" anchor="ctr"/>
+          <a:lstStyle/>
+          <a:p>
+            <a:pPr indent="0" marL="0">
+              <a:lnSpc>
+                <a:spcPct val="130000"/>
+              </a:lnSpc>
+              <a:buNone/>
+            </a:pPr>
+            <a:r>
+              <a:rPr lang="en-US" sz="1300" dirty="0">
+                <a:solidFill>
+                  <a:srgbClr val="9FB0C8"/>
+                </a:solidFill>
+                <a:latin typeface="Helvetica Neue" pitchFamily="34" charset="0"/>
+                <a:ea typeface="Helvetica Neue" pitchFamily="34" charset="-122"/>
+                <a:cs typeface="Helvetica Neue" pitchFamily="34" charset="-120"/>
+              </a:rPr>
+              <a:t>Download &amp; run the IDE on your machine — local read/write + AI, the smoothest path.</a:t>
+            </a:r>
+            <a:endParaRPr lang="en-US" sz="1300" dirty="0"/>
+          </a:p>
+        </p:txBody>
+      </p:sp>
+      <p:sp>
+        <p:nvSpPr>
+          <p:cNvPr id="11" name="Shape 9"/>
+          <p:cNvSpPr/>
+          <p:nvPr/>
+        </p:nvSpPr>
+        <p:spPr>
+          <a:xfrm>
+            <a:off x="4374794" y="2560320"/>
+            <a:ext cx="3442106" cy="2834640"/>
+          </a:xfrm>
+          <a:prstGeom prst="roundRect">
+            <a:avLst>
+              <a:gd name="adj" fmla="val 2903"/>
             </a:avLst>
           </a:prstGeom>
           <a:solidFill>
             <a:srgbClr val="FFFFFF"/>
           </a:solidFill>
-          <a:ln/>
-        </p:spPr>
-      </p:sp>
-      <p:pic>
-        <p:nvPicPr>
-          <p:cNvPr id="4" name="Image 0" descr="/Users/ivx/Documents/VLC-Marketing/brief/assets/logo.png">    </p:cNvPr>
-          <p:cNvPicPr>
-            <a:picLocks noChangeAspect="1"/>
-          </p:cNvPicPr>
-          <p:nvPr/>
-        </p:nvPicPr>
-        <p:blipFill>
-          <a:blip r:embed="rId1"/>
-          <a:stretch>
-            <a:fillRect/>
-          </a:stretch>
-        </p:blipFill>
-        <p:spPr>
-          <a:xfrm>
-            <a:off x="722376" y="758952"/>
-            <a:ext cx="1085203" cy="365760"/>
-          </a:xfrm>
-          <a:prstGeom prst="rect">
-            <a:avLst/>
-          </a:prstGeom>
-        </p:spPr>
-      </p:pic>
-      <p:sp>
-        <p:nvSpPr>
-          <p:cNvPr id="5" name="Text 2"/>
-          <p:cNvSpPr/>
-          <p:nvPr/>
-        </p:nvSpPr>
-        <p:spPr>
-          <a:xfrm>
-            <a:off x="566928" y="2148840"/>
-            <a:ext cx="11057839" cy="365760"/>
+          <a:ln w="12700">
+            <a:solidFill>
+              <a:srgbClr val="E4EAF1"/>
+            </a:solidFill>
+            <a:prstDash val="solid"/>
+          </a:ln>
+          <a:effectLst>
+            <a:outerShdw sx="100000" sy="100000" kx="0" ky="0" algn="bl" rotWithShape="0" blurRad="88900" dist="38100" dir="8100000">
+              <a:srgbClr val="0A1526">
+                <a:alpha val="10000"/>
+              </a:srgbClr>
+            </a:outerShdw>
+          </a:effectLst>
+        </p:spPr>
+      </p:sp>
+      <p:sp>
+        <p:nvSpPr>
+          <p:cNvPr id="12" name="Shape 10"/>
+          <p:cNvSpPr/>
+          <p:nvPr/>
+        </p:nvSpPr>
+        <p:spPr>
+          <a:xfrm>
+            <a:off x="4667402" y="2871216"/>
+            <a:ext cx="1371600" cy="365760"/>
+          </a:xfrm>
+          <a:prstGeom prst="roundRect">
+            <a:avLst>
+              <a:gd name="adj" fmla="val 50000"/>
+            </a:avLst>
+          </a:prstGeom>
+          <a:solidFill>
+            <a:srgbClr val="EAF2F8"/>
+          </a:solidFill>
+          <a:ln/>
+        </p:spPr>
+      </p:sp>
+      <p:sp>
+        <p:nvSpPr>
+          <p:cNvPr id="13" name="Text 11"/>
+          <p:cNvSpPr/>
+          <p:nvPr/>
+        </p:nvSpPr>
+        <p:spPr>
+          <a:xfrm>
+            <a:off x="4667402" y="2871216"/>
+            <a:ext cx="1371600" cy="365760"/>
+          </a:xfrm>
+          <a:prstGeom prst="rect">
+            <a:avLst/>
+          </a:prstGeom>
+          <a:noFill/>
+          <a:ln/>
+        </p:spPr>
+        <p:txBody>
+          <a:bodyPr wrap="square" lIns="0" tIns="0" rIns="0" bIns="0" rtlCol="0" anchor="ctr"/>
+          <a:lstStyle/>
+          <a:p>
+            <a:pPr algn="ctr" indent="0" marL="0">
+              <a:buNone/>
+            </a:pPr>
+            <a:r>
+              <a:rPr lang="en-US" sz="950" b="1" spc="100" kern="0" dirty="0">
+                <a:solidFill>
+                  <a:srgbClr val="1F4FA8"/>
+                </a:solidFill>
+                <a:latin typeface="Helvetica Neue" pitchFamily="34" charset="0"/>
+                <a:ea typeface="Helvetica Neue" pitchFamily="34" charset="-122"/>
+                <a:cs typeface="Helvetica Neue" pitchFamily="34" charset="-120"/>
+              </a:rPr>
+              <a:t>OPTIONAL</a:t>
+            </a:r>
+            <a:endParaRPr lang="en-US" sz="950" dirty="0"/>
+          </a:p>
+        </p:txBody>
+      </p:sp>
+      <p:sp>
+        <p:nvSpPr>
+          <p:cNvPr id="14" name="Text 12"/>
+          <p:cNvSpPr/>
+          <p:nvPr/>
+        </p:nvSpPr>
+        <p:spPr>
+          <a:xfrm>
+            <a:off x="4667402" y="3429000"/>
+            <a:ext cx="2856890" cy="548640"/>
           </a:xfrm>
           <a:prstGeom prst="rect">
             <a:avLst/>
@@ -10668,30 +12462,30 @@
               <a:buNone/>
             </a:pPr>
             <a:r>
-              <a:rPr lang="en-US" sz="1250" b="1" spc="300" kern="0" dirty="0">
-                <a:solidFill>
-                  <a:srgbClr val="7FE7DA"/>
-                </a:solidFill>
-                <a:latin typeface="Helvetica Neue" pitchFamily="34" charset="0"/>
-                <a:ea typeface="Helvetica Neue" pitchFamily="34" charset="-122"/>
-                <a:cs typeface="Helvetica Neue" pitchFamily="34" charset="-120"/>
-              </a:rPr>
-              <a:t>THE BET</a:t>
-            </a:r>
-            <a:endParaRPr lang="en-US" sz="1250" dirty="0"/>
-          </a:p>
-        </p:txBody>
-      </p:sp>
-      <p:sp>
-        <p:nvSpPr>
-          <p:cNvPr id="6" name="Text 3"/>
-          <p:cNvSpPr/>
-          <p:nvPr/>
-        </p:nvSpPr>
-        <p:spPr>
-          <a:xfrm>
-            <a:off x="566928" y="2560320"/>
-            <a:ext cx="11064240" cy="1737360"/>
+              <a:rPr lang="en-US" sz="1900" b="1" dirty="0">
+                <a:solidFill>
+                  <a:srgbClr val="0F1B2E"/>
+                </a:solidFill>
+                <a:latin typeface="Helvetica Neue" pitchFamily="34" charset="0"/>
+                <a:ea typeface="Helvetica Neue" pitchFamily="34" charset="-122"/>
+                <a:cs typeface="Helvetica Neue" pitchFamily="34" charset="-120"/>
+              </a:rPr>
+              <a:t>Deploy to cloud</a:t>
+            </a:r>
+            <a:endParaRPr lang="en-US" sz="1900" dirty="0"/>
+          </a:p>
+        </p:txBody>
+      </p:sp>
+      <p:sp>
+        <p:nvSpPr>
+          <p:cNvPr id="15" name="Text 13"/>
+          <p:cNvSpPr/>
+          <p:nvPr/>
+        </p:nvSpPr>
+        <p:spPr>
+          <a:xfrm>
+            <a:off x="4667402" y="4023360"/>
+            <a:ext cx="2856890" cy="1188720"/>
           </a:xfrm>
           <a:prstGeom prst="rect">
             <a:avLst/>
@@ -10705,267 +12499,258 @@
           <a:p>
             <a:pPr indent="0" marL="0">
               <a:lnSpc>
-                <a:spcPct val="105000"/>
+                <a:spcPct val="130000"/>
               </a:lnSpc>
               <a:buNone/>
             </a:pPr>
             <a:r>
-              <a:rPr lang="en-US" sz="3700" b="1" dirty="0">
-                <a:solidFill>
-                  <a:srgbClr val="FFFFFF"/>
-                </a:solidFill>
-                <a:latin typeface="Helvetica Neue" pitchFamily="34" charset="0"/>
-                <a:ea typeface="Helvetica Neue" pitchFamily="34" charset="-122"/>
-                <a:cs typeface="Helvetica Neue" pitchFamily="34" charset="-120"/>
-              </a:rPr>
-              <a:t>Whoever controls the representation layer</a:t>
-            </a:r>
-            <a:endParaRPr lang="en-US" sz="3700" dirty="0"/>
-          </a:p>
-          <a:p>
-            <a:pPr indent="0" marL="0">
-              <a:lnSpc>
-                <a:spcPct val="105000"/>
-              </a:lnSpc>
-              <a:buNone/>
-            </a:pPr>
-            <a:r>
-              <a:rPr lang="en-US" sz="3700" b="1" dirty="0">
-                <a:solidFill>
-                  <a:srgbClr val="FFFFFF"/>
-                </a:solidFill>
-                <a:latin typeface="Helvetica Neue" pitchFamily="34" charset="0"/>
-                <a:ea typeface="Helvetica Neue" pitchFamily="34" charset="-122"/>
-                <a:cs typeface="Helvetica Neue" pitchFamily="34" charset="-120"/>
-              </a:rPr>
-              <a:t>controls the </a:t>
-            </a:r>
-            <a:pPr indent="0" marL="0">
-              <a:lnSpc>
-                <a:spcPct val="105000"/>
-              </a:lnSpc>
-              <a:buNone/>
-            </a:pPr>
-            <a:r>
-              <a:rPr lang="en-US" sz="3700" b="1" dirty="0">
-                <a:solidFill>
-                  <a:srgbClr val="7FE7DA"/>
-                </a:solidFill>
-                <a:latin typeface="Helvetica Neue" pitchFamily="34" charset="0"/>
-                <a:ea typeface="Helvetica Neue" pitchFamily="34" charset="-122"/>
-                <a:cs typeface="Helvetica Neue" pitchFamily="34" charset="-120"/>
-              </a:rPr>
-              <a:t>ceiling</a:t>
-            </a:r>
-            <a:pPr indent="0" marL="0">
-              <a:lnSpc>
-                <a:spcPct val="105000"/>
-              </a:lnSpc>
-              <a:buNone/>
-            </a:pPr>
-            <a:r>
-              <a:rPr lang="en-US" sz="3700" b="1" dirty="0">
-                <a:solidFill>
-                  <a:srgbClr val="FFFFFF"/>
-                </a:solidFill>
-                <a:latin typeface="Helvetica Neue" pitchFamily="34" charset="0"/>
-                <a:ea typeface="Helvetica Neue" pitchFamily="34" charset="-122"/>
-                <a:cs typeface="Helvetica Neue" pitchFamily="34" charset="-120"/>
-              </a:rPr>
-              <a:t>.</a:t>
-            </a:r>
-            <a:endParaRPr lang="en-US" sz="3700" dirty="0"/>
-          </a:p>
-        </p:txBody>
-      </p:sp>
-      <p:sp>
-        <p:nvSpPr>
-          <p:cNvPr id="7" name="Text 4"/>
-          <p:cNvSpPr/>
-          <p:nvPr/>
-        </p:nvSpPr>
-        <p:spPr>
-          <a:xfrm>
-            <a:off x="566928" y="4389120"/>
-            <a:ext cx="10058400" cy="548640"/>
-          </a:xfrm>
-          <a:prstGeom prst="rect">
-            <a:avLst/>
-          </a:prstGeom>
-          <a:noFill/>
-          <a:ln/>
-        </p:spPr>
-        <p:txBody>
-          <a:bodyPr wrap="square" lIns="0" tIns="0" rIns="0" bIns="0" rtlCol="0" anchor="ctr"/>
-          <a:lstStyle/>
-          <a:p>
-            <a:pPr indent="0" marL="0">
-              <a:buNone/>
-            </a:pPr>
-            <a:r>
-              <a:rPr lang="en-US" sz="1600" dirty="0">
-                <a:solidFill>
-                  <a:srgbClr val="9FB0C8"/>
-                </a:solidFill>
-                <a:latin typeface="Helvetica Neue" pitchFamily="34" charset="0"/>
-                <a:ea typeface="Helvetica Neue" pitchFamily="34" charset="-122"/>
-                <a:cs typeface="Helvetica Neue" pitchFamily="34" charset="-120"/>
-              </a:rPr>
-              <a:t>AI's creativity, harnessed — not hoped for. And this is just the beginning.</a:t>
-            </a:r>
-            <a:endParaRPr lang="en-US" sz="1600" dirty="0"/>
-          </a:p>
-        </p:txBody>
-      </p:sp>
-      <p:sp>
-        <p:nvSpPr>
-          <p:cNvPr id="8" name="Shape 5"/>
-          <p:cNvSpPr/>
-          <p:nvPr/>
-        </p:nvSpPr>
-        <p:spPr>
-          <a:xfrm>
-            <a:off x="566928" y="5257800"/>
-            <a:ext cx="3520440" cy="502920"/>
+              <a:rPr lang="en-US" sz="1300" dirty="0">
+                <a:solidFill>
+                  <a:srgbClr val="2A3A51"/>
+                </a:solidFill>
+                <a:latin typeface="Helvetica Neue" pitchFamily="34" charset="0"/>
+                <a:ea typeface="Helvetica Neue" pitchFamily="34" charset="-122"/>
+                <a:cs typeface="Helvetica Neue" pitchFamily="34" charset="-120"/>
+              </a:rPr>
+              <a:t>One click to managed cloud. Pay-as-you-go compute. Zero server ops.</a:t>
+            </a:r>
+            <a:endParaRPr lang="en-US" sz="1300" dirty="0"/>
+          </a:p>
+        </p:txBody>
+      </p:sp>
+      <p:sp>
+        <p:nvSpPr>
+          <p:cNvPr id="16" name="Shape 14"/>
+          <p:cNvSpPr/>
+          <p:nvPr/>
+        </p:nvSpPr>
+        <p:spPr>
+          <a:xfrm>
+            <a:off x="8182661" y="2560320"/>
+            <a:ext cx="3442106" cy="2834640"/>
           </a:xfrm>
           <a:prstGeom prst="roundRect">
             <a:avLst>
-              <a:gd name="adj" fmla="val 18182"/>
+              <a:gd name="adj" fmla="val 2903"/>
             </a:avLst>
           </a:prstGeom>
           <a:solidFill>
-            <a:srgbClr val="15B3A4"/>
-          </a:solidFill>
-          <a:ln/>
-        </p:spPr>
-      </p:sp>
-      <p:sp>
-        <p:nvSpPr>
-          <p:cNvPr id="9" name="Text 6"/>
-          <p:cNvSpPr/>
-          <p:nvPr/>
-        </p:nvSpPr>
-        <p:spPr>
-          <a:xfrm>
-            <a:off x="566928" y="5257800"/>
-            <a:ext cx="3520440" cy="502920"/>
-          </a:xfrm>
-          <a:prstGeom prst="rect">
-            <a:avLst/>
-          </a:prstGeom>
-          <a:noFill/>
-          <a:ln/>
-        </p:spPr>
-        <p:txBody>
-          <a:bodyPr wrap="square" lIns="0" tIns="0" rIns="0" bIns="0" rtlCol="0" anchor="ctr"/>
-          <a:lstStyle/>
-          <a:p>
-            <a:pPr algn="ctr" indent="0" marL="0">
-              <a:buNone/>
-            </a:pPr>
-            <a:r>
-              <a:rPr lang="en-US" sz="1150" b="1" dirty="0">
-                <a:solidFill>
-                  <a:srgbClr val="04211D"/>
-                </a:solidFill>
-                <a:latin typeface="Helvetica Neue" pitchFamily="34" charset="0"/>
-                <a:ea typeface="Helvetica Neue" pitchFamily="34" charset="-122"/>
-                <a:cs typeface="Helvetica Neue" pitchFamily="34" charset="-120"/>
-              </a:rPr>
-              <a:t>github.com/VisualLogic-AI/VL-Code</a:t>
-            </a:r>
-            <a:endParaRPr lang="en-US" sz="1150" dirty="0"/>
-          </a:p>
-        </p:txBody>
-      </p:sp>
-      <p:sp>
-        <p:nvSpPr>
-          <p:cNvPr id="10" name="Shape 7"/>
-          <p:cNvSpPr/>
-          <p:nvPr/>
-        </p:nvSpPr>
-        <p:spPr>
-          <a:xfrm>
-            <a:off x="4315968" y="5257800"/>
-            <a:ext cx="3977640" cy="502920"/>
-          </a:xfrm>
-          <a:prstGeom prst="roundRect">
-            <a:avLst>
-              <a:gd name="adj" fmla="val 18182"/>
-            </a:avLst>
-          </a:prstGeom>
-          <a:solidFill>
-            <a:srgbClr val="102747"/>
+            <a:srgbClr val="FFFFFF"/>
           </a:solidFill>
           <a:ln w="12700">
             <a:solidFill>
-              <a:srgbClr val="26405F"/>
+              <a:srgbClr val="E4EAF1"/>
             </a:solidFill>
             <a:prstDash val="solid"/>
           </a:ln>
-        </p:spPr>
-      </p:sp>
-      <p:sp>
-        <p:nvSpPr>
-          <p:cNvPr id="11" name="Text 8"/>
-          <p:cNvSpPr/>
-          <p:nvPr/>
-        </p:nvSpPr>
-        <p:spPr>
-          <a:xfrm>
-            <a:off x="4315968" y="5257800"/>
-            <a:ext cx="3977640" cy="502920"/>
-          </a:xfrm>
-          <a:prstGeom prst="rect">
-            <a:avLst/>
-          </a:prstGeom>
-          <a:noFill/>
-          <a:ln/>
-        </p:spPr>
-        <p:txBody>
-          <a:bodyPr wrap="square" lIns="0" tIns="0" rIns="0" bIns="0" rtlCol="0" anchor="ctr"/>
-          <a:lstStyle/>
-          <a:p>
-            <a:pPr algn="ctr" indent="0" marL="0">
-              <a:buNone/>
-            </a:pPr>
-            <a:r>
-              <a:rPr lang="en-US" sz="1150" dirty="0">
-                <a:solidFill>
-                  <a:srgbClr val="7FE7DA"/>
-                </a:solidFill>
-                <a:latin typeface="Helvetica Neue" pitchFamily="34" charset="0"/>
-                <a:ea typeface="Helvetica Neue" pitchFamily="34" charset="-122"/>
-                <a:cs typeface="Helvetica Neue" pitchFamily="34" charset="-120"/>
-              </a:rPr>
-              <a:t>VisualLogic.ai-VL — language &amp; samples</a:t>
-            </a:r>
-            <a:endParaRPr lang="en-US" sz="1150" dirty="0"/>
-          </a:p>
-        </p:txBody>
-      </p:sp>
-      <p:sp>
-        <p:nvSpPr>
-          <p:cNvPr id="12" name="Shape 9"/>
-          <p:cNvSpPr/>
-          <p:nvPr/>
-        </p:nvSpPr>
-        <p:spPr>
-          <a:xfrm>
-            <a:off x="8522208" y="5257800"/>
-            <a:ext cx="2423160" cy="502920"/>
+          <a:effectLst>
+            <a:outerShdw sx="100000" sy="100000" kx="0" ky="0" algn="bl" rotWithShape="0" blurRad="88900" dist="38100" dir="8100000">
+              <a:srgbClr val="0A1526">
+                <a:alpha val="10000"/>
+              </a:srgbClr>
+            </a:outerShdw>
+          </a:effectLst>
+        </p:spPr>
+      </p:sp>
+      <p:sp>
+        <p:nvSpPr>
+          <p:cNvPr id="17" name="Shape 15"/>
+          <p:cNvSpPr/>
+          <p:nvPr/>
+        </p:nvSpPr>
+        <p:spPr>
+          <a:xfrm>
+            <a:off x="8475269" y="2871216"/>
+            <a:ext cx="1371600" cy="365760"/>
           </a:xfrm>
           <a:prstGeom prst="roundRect">
             <a:avLst>
-              <a:gd name="adj" fmla="val 18182"/>
+              <a:gd name="adj" fmla="val 50000"/>
             </a:avLst>
           </a:prstGeom>
           <a:solidFill>
-            <a:srgbClr val="102747"/>
+            <a:srgbClr val="EAF2F8"/>
           </a:solidFill>
+          <a:ln/>
+        </p:spPr>
+      </p:sp>
+      <p:sp>
+        <p:nvSpPr>
+          <p:cNvPr id="18" name="Text 16"/>
+          <p:cNvSpPr/>
+          <p:nvPr/>
+        </p:nvSpPr>
+        <p:spPr>
+          <a:xfrm>
+            <a:off x="8475269" y="2871216"/>
+            <a:ext cx="1371600" cy="365760"/>
+          </a:xfrm>
+          <a:prstGeom prst="rect">
+            <a:avLst/>
+          </a:prstGeom>
+          <a:noFill/>
+          <a:ln/>
+        </p:spPr>
+        <p:txBody>
+          <a:bodyPr wrap="square" lIns="0" tIns="0" rIns="0" bIns="0" rtlCol="0" anchor="ctr"/>
+          <a:lstStyle/>
+          <a:p>
+            <a:pPr algn="ctr" indent="0" marL="0">
+              <a:buNone/>
+            </a:pPr>
+            <a:r>
+              <a:rPr lang="en-US" sz="950" b="1" spc="100" kern="0" dirty="0">
+                <a:solidFill>
+                  <a:srgbClr val="1F4FA8"/>
+                </a:solidFill>
+                <a:latin typeface="Helvetica Neue" pitchFamily="34" charset="0"/>
+                <a:ea typeface="Helvetica Neue" pitchFamily="34" charset="-122"/>
+                <a:cs typeface="Helvetica Neue" pitchFamily="34" charset="-120"/>
+              </a:rPr>
+              <a:t>0 BINDING</a:t>
+            </a:r>
+            <a:endParaRPr lang="en-US" sz="950" dirty="0"/>
+          </a:p>
+        </p:txBody>
+      </p:sp>
+      <p:sp>
+        <p:nvSpPr>
+          <p:cNvPr id="19" name="Text 17"/>
+          <p:cNvSpPr/>
+          <p:nvPr/>
+        </p:nvSpPr>
+        <p:spPr>
+          <a:xfrm>
+            <a:off x="8475269" y="3429000"/>
+            <a:ext cx="2856890" cy="548640"/>
+          </a:xfrm>
+          <a:prstGeom prst="rect">
+            <a:avLst/>
+          </a:prstGeom>
+          <a:noFill/>
+          <a:ln/>
+        </p:spPr>
+        <p:txBody>
+          <a:bodyPr wrap="square" lIns="0" tIns="0" rIns="0" bIns="0" rtlCol="0" anchor="ctr"/>
+          <a:lstStyle/>
+          <a:p>
+            <a:pPr indent="0" marL="0">
+              <a:buNone/>
+            </a:pPr>
+            <a:r>
+              <a:rPr lang="en-US" sz="1900" b="1" dirty="0">
+                <a:solidFill>
+                  <a:srgbClr val="0F1B2E"/>
+                </a:solidFill>
+                <a:latin typeface="Helvetica Neue" pitchFamily="34" charset="0"/>
+                <a:ea typeface="Helvetica Neue" pitchFamily="34" charset="-122"/>
+                <a:cs typeface="Helvetica Neue" pitchFamily="34" charset="-120"/>
+              </a:rPr>
+              <a:t>Export source</a:t>
+            </a:r>
+            <a:endParaRPr lang="en-US" sz="1900" dirty="0"/>
+          </a:p>
+        </p:txBody>
+      </p:sp>
+      <p:sp>
+        <p:nvSpPr>
+          <p:cNvPr id="20" name="Text 18"/>
+          <p:cNvSpPr/>
+          <p:nvPr/>
+        </p:nvSpPr>
+        <p:spPr>
+          <a:xfrm>
+            <a:off x="8475269" y="4023360"/>
+            <a:ext cx="2856890" cy="1188720"/>
+          </a:xfrm>
+          <a:prstGeom prst="rect">
+            <a:avLst/>
+          </a:prstGeom>
+          <a:noFill/>
+          <a:ln/>
+        </p:spPr>
+        <p:txBody>
+          <a:bodyPr wrap="square" lIns="0" tIns="0" rIns="0" bIns="0" rtlCol="0" anchor="ctr"/>
+          <a:lstStyle/>
+          <a:p>
+            <a:pPr indent="0" marL="0">
+              <a:lnSpc>
+                <a:spcPct val="130000"/>
+              </a:lnSpc>
+              <a:buNone/>
+            </a:pPr>
+            <a:r>
+              <a:rPr lang="en-US" sz="1300" dirty="0">
+                <a:solidFill>
+                  <a:srgbClr val="2A3A51"/>
+                </a:solidFill>
+                <a:latin typeface="Helvetica Neue" pitchFamily="34" charset="0"/>
+                <a:ea typeface="Helvetica Neue" pitchFamily="34" charset="-122"/>
+                <a:cs typeface="Helvetica Neue" pitchFamily="34" charset="-120"/>
+              </a:rPr>
+              <a:t>Take the React + Node source out and self-host anywhere. Full data sovereignty.</a:t>
+            </a:r>
+            <a:endParaRPr lang="en-US" sz="1300" dirty="0"/>
+          </a:p>
+        </p:txBody>
+      </p:sp>
+      <p:sp>
+        <p:nvSpPr>
+          <p:cNvPr id="21" name="Text 19"/>
+          <p:cNvSpPr/>
+          <p:nvPr/>
+        </p:nvSpPr>
+        <p:spPr>
+          <a:xfrm>
+            <a:off x="566928" y="5623560"/>
+            <a:ext cx="11057839" cy="411480"/>
+          </a:xfrm>
+          <a:prstGeom prst="rect">
+            <a:avLst/>
+          </a:prstGeom>
+          <a:noFill/>
+          <a:ln/>
+        </p:spPr>
+        <p:txBody>
+          <a:bodyPr wrap="square" lIns="0" tIns="0" rIns="0" bIns="0" rtlCol="0" anchor="ctr"/>
+          <a:lstStyle/>
+          <a:p>
+            <a:pPr algn="ctr" indent="0" marL="0">
+              <a:buNone/>
+            </a:pPr>
+            <a:r>
+              <a:rPr lang="en-US" sz="1350" i="1" dirty="0">
+                <a:solidFill>
+                  <a:srgbClr val="0E9F91"/>
+                </a:solidFill>
+                <a:latin typeface="Helvetica Neue" pitchFamily="34" charset="0"/>
+                <a:ea typeface="Helvetica Neue" pitchFamily="34" charset="-122"/>
+                <a:cs typeface="Helvetica Neue" pitchFamily="34" charset="-120"/>
+              </a:rPr>
+              <a:t>Use the cloud when it helps — walk away with your code whenever you want.</a:t>
+            </a:r>
+            <a:endParaRPr lang="en-US" sz="1350" dirty="0"/>
+          </a:p>
+        </p:txBody>
+      </p:sp>
+      <p:sp>
+        <p:nvSpPr>
+          <p:cNvPr id="22" name="Shape 20"/>
+          <p:cNvSpPr/>
+          <p:nvPr/>
+        </p:nvSpPr>
+        <p:spPr>
+          <a:xfrm>
+            <a:off x="566928" y="6327648"/>
+            <a:ext cx="11057839" cy="0"/>
+          </a:xfrm>
+          <a:prstGeom prst="line">
+            <a:avLst/>
+          </a:prstGeom>
+          <a:noFill/>
           <a:ln w="12700">
             <a:solidFill>
-              <a:srgbClr val="26405F"/>
+              <a:srgbClr val="E4EAF1"/>
             </a:solidFill>
             <a:prstDash val="solid"/>
           </a:ln>
@@ -10973,79 +12758,93 @@
       </p:sp>
       <p:sp>
         <p:nvSpPr>
-          <p:cNvPr id="13" name="Text 10"/>
-          <p:cNvSpPr/>
-          <p:nvPr/>
-        </p:nvSpPr>
-        <p:spPr>
-          <a:xfrm>
-            <a:off x="8522208" y="5257800"/>
-            <a:ext cx="2423160" cy="502920"/>
-          </a:xfrm>
-          <a:prstGeom prst="rect">
-            <a:avLst/>
-          </a:prstGeom>
-          <a:noFill/>
-          <a:ln/>
-        </p:spPr>
-        <p:txBody>
-          <a:bodyPr wrap="square" lIns="0" tIns="0" rIns="0" bIns="0" rtlCol="0" anchor="ctr"/>
-          <a:lstStyle/>
-          <a:p>
-            <a:pPr algn="ctr" indent="0" marL="0">
-              <a:buNone/>
-            </a:pPr>
-            <a:r>
-              <a:rPr lang="en-US" sz="1150" dirty="0">
-                <a:solidFill>
-                  <a:srgbClr val="7FE7DA"/>
-                </a:solidFill>
-                <a:latin typeface="Helvetica Neue" pitchFamily="34" charset="0"/>
-                <a:ea typeface="Helvetica Neue" pitchFamily="34" charset="-122"/>
-                <a:cs typeface="Helvetica Neue" pitchFamily="34" charset="-120"/>
-              </a:rPr>
-              <a:t>editor.visuallogic.ai</a:t>
-            </a:r>
-            <a:endParaRPr lang="en-US" sz="1150" dirty="0"/>
-          </a:p>
-        </p:txBody>
-      </p:sp>
-      <p:sp>
-        <p:nvSpPr>
-          <p:cNvPr id="14" name="Text 11"/>
-          <p:cNvSpPr/>
-          <p:nvPr/>
-        </p:nvSpPr>
-        <p:spPr>
-          <a:xfrm>
-            <a:off x="566928" y="6035040"/>
-            <a:ext cx="11057839" cy="320040"/>
-          </a:xfrm>
-          <a:prstGeom prst="rect">
-            <a:avLst/>
-          </a:prstGeom>
-          <a:noFill/>
-          <a:ln/>
-        </p:spPr>
-        <p:txBody>
-          <a:bodyPr wrap="square" lIns="0" tIns="0" rIns="0" bIns="0" rtlCol="0" anchor="ctr"/>
-          <a:lstStyle/>
-          <a:p>
-            <a:pPr indent="0" marL="0">
-              <a:buNone/>
-            </a:pPr>
-            <a:r>
-              <a:rPr lang="en-US" sz="1100" dirty="0">
-                <a:solidFill>
-                  <a:srgbClr val="9FB0C8"/>
-                </a:solidFill>
-                <a:latin typeface="Helvetica Neue" pitchFamily="34" charset="0"/>
-                <a:ea typeface="Helvetica Neue" pitchFamily="34" charset="-122"/>
-                <a:cs typeface="Helvetica Neue" pitchFamily="34" charset="-120"/>
-              </a:rPr>
-              <a:t>Open source (MIT) · Local-first · An AI-native development platform</a:t>
-            </a:r>
-            <a:endParaRPr lang="en-US" sz="1100" dirty="0"/>
+          <p:cNvPr id="23" name="Text 21"/>
+          <p:cNvSpPr/>
+          <p:nvPr/>
+        </p:nvSpPr>
+        <p:spPr>
+          <a:xfrm>
+            <a:off x="566928" y="6382512"/>
+            <a:ext cx="6400800" cy="292608"/>
+          </a:xfrm>
+          <a:prstGeom prst="rect">
+            <a:avLst/>
+          </a:prstGeom>
+          <a:noFill/>
+          <a:ln/>
+        </p:spPr>
+        <p:txBody>
+          <a:bodyPr wrap="square" lIns="0" tIns="0" rIns="0" bIns="0" rtlCol="0" anchor="ctr"/>
+          <a:lstStyle/>
+          <a:p>
+            <a:pPr algn="l" indent="0" marL="0">
+              <a:buNone/>
+            </a:pPr>
+            <a:r>
+              <a:rPr lang="en-US" sz="900" b="1" dirty="0">
+                <a:solidFill>
+                  <a:srgbClr val="0E9F91"/>
+                </a:solidFill>
+                <a:latin typeface="Helvetica Neue" pitchFamily="34" charset="0"/>
+                <a:ea typeface="Helvetica Neue" pitchFamily="34" charset="-122"/>
+                <a:cs typeface="Helvetica Neue" pitchFamily="34" charset="-120"/>
+              </a:rPr>
+              <a:t>VL</a:t>
+            </a:r>
+            <a:pPr algn="l" indent="0" marL="0">
+              <a:buNone/>
+            </a:pPr>
+            <a:r>
+              <a:rPr lang="en-US" sz="900" dirty="0">
+                <a:solidFill>
+                  <a:srgbClr val="6B7C93"/>
+                </a:solidFill>
+                <a:latin typeface="Helvetica Neue" pitchFamily="34" charset="0"/>
+                <a:ea typeface="Helvetica Neue" pitchFamily="34" charset="-122"/>
+                <a:cs typeface="Helvetica Neue" pitchFamily="34" charset="-120"/>
+              </a:rPr>
+              <a:t> · CODE   ·   Tame AI inside a DAG</a:t>
+            </a:r>
+            <a:endParaRPr lang="en-US" sz="900" dirty="0"/>
+          </a:p>
+        </p:txBody>
+      </p:sp>
+      <p:sp>
+        <p:nvSpPr>
+          <p:cNvPr id="24" name="Text 22"/>
+          <p:cNvSpPr/>
+          <p:nvPr/>
+        </p:nvSpPr>
+        <p:spPr>
+          <a:xfrm>
+            <a:off x="6595567" y="6382512"/>
+            <a:ext cx="5029200" cy="292608"/>
+          </a:xfrm>
+          <a:prstGeom prst="rect">
+            <a:avLst/>
+          </a:prstGeom>
+          <a:noFill/>
+          <a:ln/>
+        </p:spPr>
+        <p:txBody>
+          <a:bodyPr wrap="square" lIns="0" tIns="0" rIns="0" bIns="0" rtlCol="0" anchor="ctr"/>
+          <a:lstStyle/>
+          <a:p>
+            <a:pPr algn="r" indent="0" marL="0">
+              <a:buNone/>
+            </a:pPr>
+            <a:r>
+              <a:rPr lang="en-US" sz="900" dirty="0">
+                <a:solidFill>
+                  <a:srgbClr val="6B7C93"/>
+                </a:solidFill>
+                <a:latin typeface="Helvetica Neue" pitchFamily="34" charset="0"/>
+                <a:ea typeface="Helvetica Neue" pitchFamily="34" charset="-122"/>
+                <a:cs typeface="Helvetica Neue" pitchFamily="34" charset="-120"/>
+              </a:rPr>
+              <a:t>github.com/VisualLogic-AI/VL-Code</a:t>
+            </a:r>
+            <a:endParaRPr lang="en-US" sz="900" dirty="0"/>
           </a:p>
         </p:txBody>
       </p:sp>
@@ -11999,6 +13798,510 @@
               <a:t>github.com/VisualLogic-AI/VL-Code</a:t>
             </a:r>
             <a:endParaRPr lang="en-US" sz="900" dirty="0"/>
+          </a:p>
+        </p:txBody>
+      </p:sp>
+    </p:spTree>
+  </p:cSld>
+  <p:clrMapOvr>
+    <a:masterClrMapping/>
+  </p:clrMapOvr>
+</p:sld>
+</file>
+
+<file path=ppt/slides/slide20.xml><?xml version="1.0" encoding="utf-8"?>
+<p:sld xmlns:a="http://schemas.openxmlformats.org/drawingml/2006/main" xmlns:r="http://schemas.openxmlformats.org/officeDocument/2006/relationships" xmlns:p="http://schemas.openxmlformats.org/presentationml/2006/main">
+  <p:cSld name="Slide 20">
+    <p:bg>
+      <p:bgPr>
+        <a:solidFill>
+          <a:srgbClr val="0A1526"/>
+        </a:solidFill>
+      </p:bgPr>
+    </p:bg>
+    <p:spTree>
+      <p:nvGrpSpPr>
+        <p:cNvPr id="1" name=""/>
+        <p:cNvGrpSpPr/>
+        <p:nvPr/>
+      </p:nvGrpSpPr>
+      <p:grpSpPr>
+        <a:xfrm>
+          <a:off x="0" y="0"/>
+          <a:ext cx="0" cy="0"/>
+          <a:chOff x="0" y="0"/>
+          <a:chExt cx="0" cy="0"/>
+        </a:xfrm>
+      </p:grpSpPr>
+      <p:sp>
+        <p:nvSpPr>
+          <p:cNvPr id="2" name="Shape 0"/>
+          <p:cNvSpPr/>
+          <p:nvPr/>
+        </p:nvSpPr>
+        <p:spPr>
+          <a:xfrm>
+            <a:off x="0" y="6711696"/>
+            <a:ext cx="12191695" cy="146304"/>
+          </a:xfrm>
+          <a:prstGeom prst="rect">
+            <a:avLst/>
+          </a:prstGeom>
+          <a:solidFill>
+            <a:srgbClr val="15B3A4"/>
+          </a:solidFill>
+          <a:ln/>
+        </p:spPr>
+      </p:sp>
+      <p:sp>
+        <p:nvSpPr>
+          <p:cNvPr id="3" name="Shape 1"/>
+          <p:cNvSpPr/>
+          <p:nvPr/>
+        </p:nvSpPr>
+        <p:spPr>
+          <a:xfrm>
+            <a:off x="566928" y="640080"/>
+            <a:ext cx="1396099" cy="603504"/>
+          </a:xfrm>
+          <a:prstGeom prst="roundRect">
+            <a:avLst>
+              <a:gd name="adj" fmla="val 12121"/>
+            </a:avLst>
+          </a:prstGeom>
+          <a:solidFill>
+            <a:srgbClr val="FFFFFF"/>
+          </a:solidFill>
+          <a:ln/>
+        </p:spPr>
+      </p:sp>
+      <p:pic>
+        <p:nvPicPr>
+          <p:cNvPr id="4" name="Image 0" descr="/Users/ivx/Documents/VLC-Marketing/brief/assets/logo.png">    </p:cNvPr>
+          <p:cNvPicPr>
+            <a:picLocks noChangeAspect="1"/>
+          </p:cNvPicPr>
+          <p:nvPr/>
+        </p:nvPicPr>
+        <p:blipFill>
+          <a:blip r:embed="rId1"/>
+          <a:stretch>
+            <a:fillRect/>
+          </a:stretch>
+        </p:blipFill>
+        <p:spPr>
+          <a:xfrm>
+            <a:off x="722376" y="758952"/>
+            <a:ext cx="1085203" cy="365760"/>
+          </a:xfrm>
+          <a:prstGeom prst="rect">
+            <a:avLst/>
+          </a:prstGeom>
+        </p:spPr>
+      </p:pic>
+      <p:sp>
+        <p:nvSpPr>
+          <p:cNvPr id="5" name="Text 2"/>
+          <p:cNvSpPr/>
+          <p:nvPr/>
+        </p:nvSpPr>
+        <p:spPr>
+          <a:xfrm>
+            <a:off x="566928" y="2148840"/>
+            <a:ext cx="11057839" cy="365760"/>
+          </a:xfrm>
+          <a:prstGeom prst="rect">
+            <a:avLst/>
+          </a:prstGeom>
+          <a:noFill/>
+          <a:ln/>
+        </p:spPr>
+        <p:txBody>
+          <a:bodyPr wrap="square" lIns="0" tIns="0" rIns="0" bIns="0" rtlCol="0" anchor="ctr"/>
+          <a:lstStyle/>
+          <a:p>
+            <a:pPr indent="0" marL="0">
+              <a:buNone/>
+            </a:pPr>
+            <a:r>
+              <a:rPr lang="en-US" sz="1250" b="1" spc="300" kern="0" dirty="0">
+                <a:solidFill>
+                  <a:srgbClr val="7FE7DA"/>
+                </a:solidFill>
+                <a:latin typeface="Helvetica Neue" pitchFamily="34" charset="0"/>
+                <a:ea typeface="Helvetica Neue" pitchFamily="34" charset="-122"/>
+                <a:cs typeface="Helvetica Neue" pitchFamily="34" charset="-120"/>
+              </a:rPr>
+              <a:t>THE BET</a:t>
+            </a:r>
+            <a:endParaRPr lang="en-US" sz="1250" dirty="0"/>
+          </a:p>
+        </p:txBody>
+      </p:sp>
+      <p:sp>
+        <p:nvSpPr>
+          <p:cNvPr id="6" name="Text 3"/>
+          <p:cNvSpPr/>
+          <p:nvPr/>
+        </p:nvSpPr>
+        <p:spPr>
+          <a:xfrm>
+            <a:off x="566928" y="2560320"/>
+            <a:ext cx="11064240" cy="1737360"/>
+          </a:xfrm>
+          <a:prstGeom prst="rect">
+            <a:avLst/>
+          </a:prstGeom>
+          <a:noFill/>
+          <a:ln/>
+        </p:spPr>
+        <p:txBody>
+          <a:bodyPr wrap="square" lIns="0" tIns="0" rIns="0" bIns="0" rtlCol="0" anchor="ctr"/>
+          <a:lstStyle/>
+          <a:p>
+            <a:pPr indent="0" marL="0">
+              <a:lnSpc>
+                <a:spcPct val="105000"/>
+              </a:lnSpc>
+              <a:buNone/>
+            </a:pPr>
+            <a:r>
+              <a:rPr lang="en-US" sz="3700" b="1" dirty="0">
+                <a:solidFill>
+                  <a:srgbClr val="FFFFFF"/>
+                </a:solidFill>
+                <a:latin typeface="Helvetica Neue" pitchFamily="34" charset="0"/>
+                <a:ea typeface="Helvetica Neue" pitchFamily="34" charset="-122"/>
+                <a:cs typeface="Helvetica Neue" pitchFamily="34" charset="-120"/>
+              </a:rPr>
+              <a:t>Whoever controls the representation layer</a:t>
+            </a:r>
+            <a:endParaRPr lang="en-US" sz="3700" dirty="0"/>
+          </a:p>
+          <a:p>
+            <a:pPr indent="0" marL="0">
+              <a:lnSpc>
+                <a:spcPct val="105000"/>
+              </a:lnSpc>
+              <a:buNone/>
+            </a:pPr>
+            <a:r>
+              <a:rPr lang="en-US" sz="3700" b="1" dirty="0">
+                <a:solidFill>
+                  <a:srgbClr val="FFFFFF"/>
+                </a:solidFill>
+                <a:latin typeface="Helvetica Neue" pitchFamily="34" charset="0"/>
+                <a:ea typeface="Helvetica Neue" pitchFamily="34" charset="-122"/>
+                <a:cs typeface="Helvetica Neue" pitchFamily="34" charset="-120"/>
+              </a:rPr>
+              <a:t>controls the </a:t>
+            </a:r>
+            <a:pPr indent="0" marL="0">
+              <a:lnSpc>
+                <a:spcPct val="105000"/>
+              </a:lnSpc>
+              <a:buNone/>
+            </a:pPr>
+            <a:r>
+              <a:rPr lang="en-US" sz="3700" b="1" dirty="0">
+                <a:solidFill>
+                  <a:srgbClr val="7FE7DA"/>
+                </a:solidFill>
+                <a:latin typeface="Helvetica Neue" pitchFamily="34" charset="0"/>
+                <a:ea typeface="Helvetica Neue" pitchFamily="34" charset="-122"/>
+                <a:cs typeface="Helvetica Neue" pitchFamily="34" charset="-120"/>
+              </a:rPr>
+              <a:t>ceiling</a:t>
+            </a:r>
+            <a:pPr indent="0" marL="0">
+              <a:lnSpc>
+                <a:spcPct val="105000"/>
+              </a:lnSpc>
+              <a:buNone/>
+            </a:pPr>
+            <a:r>
+              <a:rPr lang="en-US" sz="3700" b="1" dirty="0">
+                <a:solidFill>
+                  <a:srgbClr val="FFFFFF"/>
+                </a:solidFill>
+                <a:latin typeface="Helvetica Neue" pitchFamily="34" charset="0"/>
+                <a:ea typeface="Helvetica Neue" pitchFamily="34" charset="-122"/>
+                <a:cs typeface="Helvetica Neue" pitchFamily="34" charset="-120"/>
+              </a:rPr>
+              <a:t>.</a:t>
+            </a:r>
+            <a:endParaRPr lang="en-US" sz="3700" dirty="0"/>
+          </a:p>
+        </p:txBody>
+      </p:sp>
+      <p:sp>
+        <p:nvSpPr>
+          <p:cNvPr id="7" name="Text 4"/>
+          <p:cNvSpPr/>
+          <p:nvPr/>
+        </p:nvSpPr>
+        <p:spPr>
+          <a:xfrm>
+            <a:off x="566928" y="4389120"/>
+            <a:ext cx="10058400" cy="548640"/>
+          </a:xfrm>
+          <a:prstGeom prst="rect">
+            <a:avLst/>
+          </a:prstGeom>
+          <a:noFill/>
+          <a:ln/>
+        </p:spPr>
+        <p:txBody>
+          <a:bodyPr wrap="square" lIns="0" tIns="0" rIns="0" bIns="0" rtlCol="0" anchor="ctr"/>
+          <a:lstStyle/>
+          <a:p>
+            <a:pPr indent="0" marL="0">
+              <a:buNone/>
+            </a:pPr>
+            <a:r>
+              <a:rPr lang="en-US" sz="1600" dirty="0">
+                <a:solidFill>
+                  <a:srgbClr val="9FB0C8"/>
+                </a:solidFill>
+                <a:latin typeface="Helvetica Neue" pitchFamily="34" charset="0"/>
+                <a:ea typeface="Helvetica Neue" pitchFamily="34" charset="-122"/>
+                <a:cs typeface="Helvetica Neue" pitchFamily="34" charset="-120"/>
+              </a:rPr>
+              <a:t>AI's creativity, harnessed — not hoped for. And this is just the beginning.</a:t>
+            </a:r>
+            <a:endParaRPr lang="en-US" sz="1600" dirty="0"/>
+          </a:p>
+        </p:txBody>
+      </p:sp>
+      <p:sp>
+        <p:nvSpPr>
+          <p:cNvPr id="8" name="Shape 5"/>
+          <p:cNvSpPr/>
+          <p:nvPr/>
+        </p:nvSpPr>
+        <p:spPr>
+          <a:xfrm>
+            <a:off x="566928" y="5257800"/>
+            <a:ext cx="3520440" cy="502920"/>
+          </a:xfrm>
+          <a:prstGeom prst="roundRect">
+            <a:avLst>
+              <a:gd name="adj" fmla="val 18182"/>
+            </a:avLst>
+          </a:prstGeom>
+          <a:solidFill>
+            <a:srgbClr val="15B3A4"/>
+          </a:solidFill>
+          <a:ln/>
+        </p:spPr>
+      </p:sp>
+      <p:sp>
+        <p:nvSpPr>
+          <p:cNvPr id="9" name="Text 6"/>
+          <p:cNvSpPr/>
+          <p:nvPr/>
+        </p:nvSpPr>
+        <p:spPr>
+          <a:xfrm>
+            <a:off x="566928" y="5257800"/>
+            <a:ext cx="3520440" cy="502920"/>
+          </a:xfrm>
+          <a:prstGeom prst="rect">
+            <a:avLst/>
+          </a:prstGeom>
+          <a:noFill/>
+          <a:ln/>
+        </p:spPr>
+        <p:txBody>
+          <a:bodyPr wrap="square" lIns="0" tIns="0" rIns="0" bIns="0" rtlCol="0" anchor="ctr"/>
+          <a:lstStyle/>
+          <a:p>
+            <a:pPr algn="ctr" indent="0" marL="0">
+              <a:buNone/>
+            </a:pPr>
+            <a:r>
+              <a:rPr lang="en-US" sz="1150" b="1" dirty="0">
+                <a:solidFill>
+                  <a:srgbClr val="04211D"/>
+                </a:solidFill>
+                <a:latin typeface="Helvetica Neue" pitchFamily="34" charset="0"/>
+                <a:ea typeface="Helvetica Neue" pitchFamily="34" charset="-122"/>
+                <a:cs typeface="Helvetica Neue" pitchFamily="34" charset="-120"/>
+              </a:rPr>
+              <a:t>github.com/VisualLogic-AI/VL-Code</a:t>
+            </a:r>
+            <a:endParaRPr lang="en-US" sz="1150" dirty="0"/>
+          </a:p>
+        </p:txBody>
+      </p:sp>
+      <p:sp>
+        <p:nvSpPr>
+          <p:cNvPr id="10" name="Shape 7"/>
+          <p:cNvSpPr/>
+          <p:nvPr/>
+        </p:nvSpPr>
+        <p:spPr>
+          <a:xfrm>
+            <a:off x="4315968" y="5257800"/>
+            <a:ext cx="3977640" cy="502920"/>
+          </a:xfrm>
+          <a:prstGeom prst="roundRect">
+            <a:avLst>
+              <a:gd name="adj" fmla="val 18182"/>
+            </a:avLst>
+          </a:prstGeom>
+          <a:solidFill>
+            <a:srgbClr val="102747"/>
+          </a:solidFill>
+          <a:ln w="12700">
+            <a:solidFill>
+              <a:srgbClr val="26405F"/>
+            </a:solidFill>
+            <a:prstDash val="solid"/>
+          </a:ln>
+        </p:spPr>
+      </p:sp>
+      <p:sp>
+        <p:nvSpPr>
+          <p:cNvPr id="11" name="Text 8"/>
+          <p:cNvSpPr/>
+          <p:nvPr/>
+        </p:nvSpPr>
+        <p:spPr>
+          <a:xfrm>
+            <a:off x="4315968" y="5257800"/>
+            <a:ext cx="3977640" cy="502920"/>
+          </a:xfrm>
+          <a:prstGeom prst="rect">
+            <a:avLst/>
+          </a:prstGeom>
+          <a:noFill/>
+          <a:ln/>
+        </p:spPr>
+        <p:txBody>
+          <a:bodyPr wrap="square" lIns="0" tIns="0" rIns="0" bIns="0" rtlCol="0" anchor="ctr"/>
+          <a:lstStyle/>
+          <a:p>
+            <a:pPr algn="ctr" indent="0" marL="0">
+              <a:buNone/>
+            </a:pPr>
+            <a:r>
+              <a:rPr lang="en-US" sz="1150" dirty="0">
+                <a:solidFill>
+                  <a:srgbClr val="7FE7DA"/>
+                </a:solidFill>
+                <a:latin typeface="Helvetica Neue" pitchFamily="34" charset="0"/>
+                <a:ea typeface="Helvetica Neue" pitchFamily="34" charset="-122"/>
+                <a:cs typeface="Helvetica Neue" pitchFamily="34" charset="-120"/>
+              </a:rPr>
+              <a:t>VisualLogic.ai-VL — language &amp; samples</a:t>
+            </a:r>
+            <a:endParaRPr lang="en-US" sz="1150" dirty="0"/>
+          </a:p>
+        </p:txBody>
+      </p:sp>
+      <p:sp>
+        <p:nvSpPr>
+          <p:cNvPr id="12" name="Shape 9"/>
+          <p:cNvSpPr/>
+          <p:nvPr/>
+        </p:nvSpPr>
+        <p:spPr>
+          <a:xfrm>
+            <a:off x="8522208" y="5257800"/>
+            <a:ext cx="2423160" cy="502920"/>
+          </a:xfrm>
+          <a:prstGeom prst="roundRect">
+            <a:avLst>
+              <a:gd name="adj" fmla="val 18182"/>
+            </a:avLst>
+          </a:prstGeom>
+          <a:solidFill>
+            <a:srgbClr val="102747"/>
+          </a:solidFill>
+          <a:ln w="12700">
+            <a:solidFill>
+              <a:srgbClr val="26405F"/>
+            </a:solidFill>
+            <a:prstDash val="solid"/>
+          </a:ln>
+        </p:spPr>
+      </p:sp>
+      <p:sp>
+        <p:nvSpPr>
+          <p:cNvPr id="13" name="Text 10"/>
+          <p:cNvSpPr/>
+          <p:nvPr/>
+        </p:nvSpPr>
+        <p:spPr>
+          <a:xfrm>
+            <a:off x="8522208" y="5257800"/>
+            <a:ext cx="2423160" cy="502920"/>
+          </a:xfrm>
+          <a:prstGeom prst="rect">
+            <a:avLst/>
+          </a:prstGeom>
+          <a:noFill/>
+          <a:ln/>
+        </p:spPr>
+        <p:txBody>
+          <a:bodyPr wrap="square" lIns="0" tIns="0" rIns="0" bIns="0" rtlCol="0" anchor="ctr"/>
+          <a:lstStyle/>
+          <a:p>
+            <a:pPr algn="ctr" indent="0" marL="0">
+              <a:buNone/>
+            </a:pPr>
+            <a:r>
+              <a:rPr lang="en-US" sz="1150" dirty="0">
+                <a:solidFill>
+                  <a:srgbClr val="7FE7DA"/>
+                </a:solidFill>
+                <a:latin typeface="Helvetica Neue" pitchFamily="34" charset="0"/>
+                <a:ea typeface="Helvetica Neue" pitchFamily="34" charset="-122"/>
+                <a:cs typeface="Helvetica Neue" pitchFamily="34" charset="-120"/>
+              </a:rPr>
+              <a:t>editor.visuallogic.ai</a:t>
+            </a:r>
+            <a:endParaRPr lang="en-US" sz="1150" dirty="0"/>
+          </a:p>
+        </p:txBody>
+      </p:sp>
+      <p:sp>
+        <p:nvSpPr>
+          <p:cNvPr id="14" name="Text 11"/>
+          <p:cNvSpPr/>
+          <p:nvPr/>
+        </p:nvSpPr>
+        <p:spPr>
+          <a:xfrm>
+            <a:off x="566928" y="6035040"/>
+            <a:ext cx="11057839" cy="320040"/>
+          </a:xfrm>
+          <a:prstGeom prst="rect">
+            <a:avLst/>
+          </a:prstGeom>
+          <a:noFill/>
+          <a:ln/>
+        </p:spPr>
+        <p:txBody>
+          <a:bodyPr wrap="square" lIns="0" tIns="0" rIns="0" bIns="0" rtlCol="0" anchor="ctr"/>
+          <a:lstStyle/>
+          <a:p>
+            <a:pPr indent="0" marL="0">
+              <a:buNone/>
+            </a:pPr>
+            <a:r>
+              <a:rPr lang="en-US" sz="1100" dirty="0">
+                <a:solidFill>
+                  <a:srgbClr val="9FB0C8"/>
+                </a:solidFill>
+                <a:latin typeface="Helvetica Neue" pitchFamily="34" charset="0"/>
+                <a:ea typeface="Helvetica Neue" pitchFamily="34" charset="-122"/>
+                <a:cs typeface="Helvetica Neue" pitchFamily="34" charset="-120"/>
+              </a:rPr>
+              <a:t>Open source (MIT) · Local-first · An AI-native development platform</a:t>
+            </a:r>
+            <a:endParaRPr lang="en-US" sz="1100" dirty="0"/>
           </a:p>
         </p:txBody>
       </p:sp>

</xml_diff>